<commit_message>
feat: real visuals - density surface, DIS flow, pressure trace, Kumbh photo, full 22-source reference wall
</commit_message>
<xml_diff>
--- a/deck/Raksha_Hackathon2026_Simplified.pptx
+++ b/deck/Raksha_Hackathon2026_Simplified.pptx
@@ -5815,7 +5815,7 @@
         <p:spPr>
           <a:xfrm>
             <a:off x="10104120" y="3474720"/>
-            <a:ext cx="6949440" cy="868680"/>
+            <a:ext cx="3017520" cy="868680"/>
           </a:xfrm>
           <a:prstGeom prst="rect">
             <a:avLst/>
@@ -5903,7 +5903,7 @@
         <p:spPr>
           <a:xfrm>
             <a:off x="10104120" y="4572000"/>
-            <a:ext cx="6949440" cy="868680"/>
+            <a:ext cx="3017520" cy="868680"/>
           </a:xfrm>
           <a:prstGeom prst="rect">
             <a:avLst/>
@@ -5991,7 +5991,7 @@
         <p:spPr>
           <a:xfrm>
             <a:off x="10104120" y="5669280"/>
-            <a:ext cx="6949440" cy="868680"/>
+            <a:ext cx="3017520" cy="868680"/>
           </a:xfrm>
           <a:prstGeom prst="rect">
             <a:avLst/>
@@ -6155,6 +6155,66 @@
                 <a:latin typeface="Calibri"/>
               </a:rPr>
               <a:t>A stopped crowd is not a warning. It is the accident. Pressure passes body to body long before feet stop. That is why cameras must read force, not faces.</a:t>
+            </a:r>
+          </a:p>
+        </p:txBody>
+      </p:sp>
+      <p:pic>
+        <p:nvPicPr>
+          <p:cNvPr id="133" name="P2 kumbh" descr="kumbh_crowd.jpg"/>
+          <p:cNvPicPr>
+            <a:picLocks noChangeAspect="1"/>
+          </p:cNvPicPr>
+          <p:nvPr/>
+        </p:nvPicPr>
+        <p:blipFill>
+          <a:blip r:embed="rId3"/>
+          <a:stretch>
+            <a:fillRect/>
+          </a:stretch>
+        </p:blipFill>
+        <p:spPr>
+          <a:xfrm>
+            <a:off x="13441680" y="3566160"/>
+            <a:ext cx="3566160" cy="2002536"/>
+          </a:xfrm>
+          <a:prstGeom prst="rect">
+            <a:avLst/>
+          </a:prstGeom>
+          <a:ln>
+            <a:noFill/>
+          </a:ln>
+        </p:spPr>
+      </p:pic>
+      <p:sp>
+        <p:nvSpPr>
+          <p:cNvPr id="134" name="P2 kumbhc"/>
+          <p:cNvSpPr txBox="1"/>
+          <p:nvPr/>
+        </p:nvSpPr>
+        <p:spPr>
+          <a:xfrm>
+            <a:off x="13441680" y="5623560"/>
+            <a:ext cx="3566160" cy="822960"/>
+          </a:xfrm>
+          <a:prstGeom prst="rect">
+            <a:avLst/>
+          </a:prstGeom>
+          <a:noFill/>
+        </p:spPr>
+        <p:txBody>
+          <a:bodyPr wrap="square" anchor="ctr" lIns="45720" rIns="45720" tIns="18288" bIns="18288"/>
+          <a:lstStyle/>
+          <a:p>
+            <a:pPr algn="l"/>
+            <a:r>
+              <a:rPr sz="1100" b="0" i="0">
+                <a:solidFill>
+                  <a:srgbClr val="5A5A5A"/>
+                </a:solidFill>
+                <a:latin typeface="Calibri"/>
+              </a:rPr>
+              <a:t>Kumbh mela ground at night, Jan 2025. Photo: Wikimedia Commons.</a:t>
             </a:r>
           </a:p>
         </p:txBody>
@@ -6925,13 +6985,13 @@
           <a:p>
             <a:pPr algn="l"/>
             <a:r>
-              <a:rPr sz="1350" b="0" i="0">
+              <a:rPr sz="1300" b="0" i="0">
                 <a:solidFill>
                   <a:srgbClr val="111111"/>
                 </a:solidFill>
                 <a:latin typeface="Calibri"/>
               </a:rPr>
-              <a:t>At crush density a detector scores F1 0.07 against 0.71 point-based. (NWPU-Crowd)</a:t>
+              <a:t>At crush density a detector scores F1 0.07 against 0.71 point-based. Counting error fell from 68 to 49 MAE. (NWPU-Crowd, ShanghaiTech)</a:t>
             </a:r>
           </a:p>
         </p:txBody>
@@ -7168,7 +7228,7 @@
         <p:spPr>
           <a:xfrm>
             <a:off x="960120" y="6126480"/>
-            <a:ext cx="6309360" cy="502920"/>
+            <a:ext cx="6309360" cy="411480"/>
           </a:xfrm>
           <a:prstGeom prst="rect">
             <a:avLst/>
@@ -7187,140 +7247,108 @@
                 </a:solidFill>
                 <a:latin typeface="Calibri"/>
               </a:rPr>
-              <a:t>Count error keeps falling (MAE, lower is better)</a:t>
-            </a:r>
-          </a:p>
-        </p:txBody>
-      </p:sp>
-      <p:sp>
-        <p:nvSpPr>
-          <p:cNvPr id="121" name="P3 lbl"/>
-          <p:cNvSpPr txBox="1"/>
-          <p:nvPr/>
-        </p:nvSpPr>
-        <p:spPr>
-          <a:xfrm>
-            <a:off x="960120" y="6812280"/>
-            <a:ext cx="1554480" cy="502920"/>
+              <a:t>What the machine sees</a:t>
+            </a:r>
+          </a:p>
+        </p:txBody>
+      </p:sp>
+      <p:pic>
+        <p:nvPicPr>
+          <p:cNvPr id="121" name="P3 density" descr="jh_fig3_new.png"/>
+          <p:cNvPicPr>
+            <a:picLocks noChangeAspect="1"/>
+          </p:cNvPicPr>
+          <p:nvPr/>
+        </p:nvPicPr>
+        <p:blipFill>
+          <a:blip r:embed="rId3"/>
+          <a:stretch>
+            <a:fillRect/>
+          </a:stretch>
+        </p:blipFill>
+        <p:spPr>
+          <a:xfrm>
+            <a:off x="960120" y="6583680"/>
+            <a:ext cx="2743200" cy="2423160"/>
           </a:xfrm>
           <a:prstGeom prst="rect">
             <a:avLst/>
           </a:prstGeom>
-          <a:noFill/>
-        </p:spPr>
-        <p:txBody>
-          <a:bodyPr wrap="square" anchor="ctr" lIns="45720" rIns="45720" tIns="18288" bIns="18288"/>
-          <a:lstStyle/>
-          <a:p>
-            <a:pPr algn="r"/>
-            <a:r>
-              <a:rPr sz="1300" b="0" i="0">
-                <a:solidFill>
-                  <a:srgbClr val="1E2761"/>
-                </a:solidFill>
-                <a:latin typeface="Calibri"/>
-              </a:rPr>
-              <a:t>CSRNet</a:t>
-            </a:r>
-          </a:p>
-        </p:txBody>
-      </p:sp>
-      <p:sp>
-        <p:nvSpPr>
-          <p:cNvPr id="122" name="P3 track"/>
-          <p:cNvSpPr/>
-          <p:nvPr/>
-        </p:nvSpPr>
-        <p:spPr>
-          <a:xfrm>
-            <a:off x="2606040" y="6903720"/>
-            <a:ext cx="3291840" cy="292608"/>
-          </a:xfrm>
-          <a:prstGeom prst="rect">
-            <a:avLst/>
-          </a:prstGeom>
-          <a:solidFill>
-            <a:srgbClr val="D5DBEA"/>
-          </a:solidFill>
           <a:ln>
             <a:noFill/>
           </a:ln>
         </p:spPr>
-        <p:style>
-          <a:lnRef idx="1">
-            <a:schemeClr val="accent1"/>
-          </a:lnRef>
-          <a:fillRef idx="3">
-            <a:schemeClr val="accent1"/>
-          </a:fillRef>
-          <a:effectRef idx="2">
-            <a:schemeClr val="accent1"/>
-          </a:effectRef>
-          <a:fontRef idx="minor">
-            <a:schemeClr val="lt1"/>
-          </a:fontRef>
-        </p:style>
-        <p:txBody>
-          <a:bodyPr rtlCol="0" anchor="ctr"/>
-          <a:lstStyle/>
-          <a:p>
-            <a:pPr algn="ctr"/>
-          </a:p>
-        </p:txBody>
-      </p:sp>
-      <p:sp>
-        <p:nvSpPr>
-          <p:cNvPr id="123" name="P3 fill"/>
-          <p:cNvSpPr/>
-          <p:nvPr/>
-        </p:nvSpPr>
-        <p:spPr>
-          <a:xfrm>
-            <a:off x="2606040" y="6903720"/>
-            <a:ext cx="3197787" cy="292608"/>
+      </p:pic>
+      <p:sp>
+        <p:nvSpPr>
+          <p:cNvPr id="122" name="P3 densityc"/>
+          <p:cNvSpPr txBox="1"/>
+          <p:nvPr/>
+        </p:nvSpPr>
+        <p:spPr>
+          <a:xfrm>
+            <a:off x="960120" y="9034272"/>
+            <a:ext cx="2743200" cy="502920"/>
           </a:xfrm>
           <a:prstGeom prst="rect">
             <a:avLst/>
           </a:prstGeom>
-          <a:solidFill>
-            <a:srgbClr val="1E2761"/>
-          </a:solidFill>
+          <a:noFill/>
+        </p:spPr>
+        <p:txBody>
+          <a:bodyPr wrap="square" anchor="ctr" lIns="45720" rIns="45720" tIns="18288" bIns="18288"/>
+          <a:lstStyle/>
+          <a:p>
+            <a:pPr algn="l"/>
+            <a:r>
+              <a:rPr sz="1050" b="0" i="0">
+                <a:solidFill>
+                  <a:srgbClr val="5A5A5A"/>
+                </a:solidFill>
+                <a:latin typeface="Calibri"/>
+              </a:rPr>
+              <a:t>Head-density surface from video (Johansson 2008).</a:t>
+            </a:r>
+          </a:p>
+        </p:txBody>
+      </p:sp>
+      <p:pic>
+        <p:nvPicPr>
+          <p:cNvPr id="123" name="P3 flow" descr="dis_flow.png"/>
+          <p:cNvPicPr>
+            <a:picLocks noChangeAspect="1"/>
+          </p:cNvPicPr>
+          <p:nvPr/>
+        </p:nvPicPr>
+        <p:blipFill>
+          <a:blip r:embed="rId5"/>
+          <a:stretch>
+            <a:fillRect/>
+          </a:stretch>
+        </p:blipFill>
+        <p:spPr>
+          <a:xfrm>
+            <a:off x="3840480" y="6583680"/>
+            <a:ext cx="3429000" cy="960120"/>
+          </a:xfrm>
+          <a:prstGeom prst="rect">
+            <a:avLst/>
+          </a:prstGeom>
           <a:ln>
             <a:noFill/>
           </a:ln>
         </p:spPr>
-        <p:style>
-          <a:lnRef idx="1">
-            <a:schemeClr val="accent1"/>
-          </a:lnRef>
-          <a:fillRef idx="3">
-            <a:schemeClr val="accent1"/>
-          </a:fillRef>
-          <a:effectRef idx="2">
-            <a:schemeClr val="accent1"/>
-          </a:effectRef>
-          <a:fontRef idx="minor">
-            <a:schemeClr val="lt1"/>
-          </a:fontRef>
-        </p:style>
-        <p:txBody>
-          <a:bodyPr rtlCol="0" anchor="ctr"/>
-          <a:lstStyle/>
-          <a:p>
-            <a:pPr algn="ctr"/>
-          </a:p>
-        </p:txBody>
-      </p:sp>
-      <p:sp>
-        <p:nvSpPr>
-          <p:cNvPr id="124" name="P3 val"/>
+      </p:pic>
+      <p:sp>
+        <p:nvSpPr>
+          <p:cNvPr id="124" name="P3 flowc"/>
           <p:cNvSpPr txBox="1"/>
           <p:nvPr/>
         </p:nvSpPr>
         <p:spPr>
           <a:xfrm>
-            <a:off x="6035040" y="6812280"/>
-            <a:ext cx="822960" cy="502920"/>
+            <a:off x="3840480" y="7589520"/>
+            <a:ext cx="3429000" cy="1920240"/>
           </a:xfrm>
           <a:prstGeom prst="rect">
             <a:avLst/>
@@ -7333,469 +7361,13 @@
           <a:p>
             <a:pPr algn="l"/>
             <a:r>
-              <a:rPr sz="1300" b="1" i="0">
-                <a:solidFill>
-                  <a:srgbClr val="1E2761"/>
-                </a:solidFill>
-                <a:latin typeface="Calibri"/>
-              </a:rPr>
-              <a:t>68</a:t>
-            </a:r>
-          </a:p>
-        </p:txBody>
-      </p:sp>
-      <p:sp>
-        <p:nvSpPr>
-          <p:cNvPr id="125" name="P3 lbl"/>
-          <p:cNvSpPr txBox="1"/>
-          <p:nvPr/>
-        </p:nvSpPr>
-        <p:spPr>
-          <a:xfrm>
-            <a:off x="960120" y="7543800"/>
-            <a:ext cx="1554480" cy="502920"/>
-          </a:xfrm>
-          <a:prstGeom prst="rect">
-            <a:avLst/>
-          </a:prstGeom>
-          <a:noFill/>
-        </p:spPr>
-        <p:txBody>
-          <a:bodyPr wrap="square" anchor="ctr" lIns="45720" rIns="45720" tIns="18288" bIns="18288"/>
-          <a:lstStyle/>
-          <a:p>
-            <a:pPr algn="r"/>
-            <a:r>
-              <a:rPr sz="1300" b="0" i="0">
-                <a:solidFill>
-                  <a:srgbClr val="1E2761"/>
-                </a:solidFill>
-                <a:latin typeface="Calibri"/>
-              </a:rPr>
-              <a:t>Bayesian</a:t>
-            </a:r>
-          </a:p>
-        </p:txBody>
-      </p:sp>
-      <p:sp>
-        <p:nvSpPr>
-          <p:cNvPr id="126" name="P3 track"/>
-          <p:cNvSpPr/>
-          <p:nvPr/>
-        </p:nvSpPr>
-        <p:spPr>
-          <a:xfrm>
-            <a:off x="2606040" y="7635240"/>
-            <a:ext cx="3291840" cy="292608"/>
-          </a:xfrm>
-          <a:prstGeom prst="rect">
-            <a:avLst/>
-          </a:prstGeom>
-          <a:solidFill>
-            <a:srgbClr val="D5DBEA"/>
-          </a:solidFill>
-          <a:ln>
-            <a:noFill/>
-          </a:ln>
-        </p:spPr>
-        <p:style>
-          <a:lnRef idx="1">
-            <a:schemeClr val="accent1"/>
-          </a:lnRef>
-          <a:fillRef idx="3">
-            <a:schemeClr val="accent1"/>
-          </a:fillRef>
-          <a:effectRef idx="2">
-            <a:schemeClr val="accent1"/>
-          </a:effectRef>
-          <a:fontRef idx="minor">
-            <a:schemeClr val="lt1"/>
-          </a:fontRef>
-        </p:style>
-        <p:txBody>
-          <a:bodyPr rtlCol="0" anchor="ctr"/>
-          <a:lstStyle/>
-          <a:p>
-            <a:pPr algn="ctr"/>
-          </a:p>
-        </p:txBody>
-      </p:sp>
-      <p:sp>
-        <p:nvSpPr>
-          <p:cNvPr id="127" name="P3 fill"/>
-          <p:cNvSpPr/>
-          <p:nvPr/>
-        </p:nvSpPr>
-        <p:spPr>
-          <a:xfrm>
-            <a:off x="2606040" y="7635240"/>
-            <a:ext cx="2962656" cy="292608"/>
-          </a:xfrm>
-          <a:prstGeom prst="rect">
-            <a:avLst/>
-          </a:prstGeom>
-          <a:solidFill>
-            <a:srgbClr val="1E2761"/>
-          </a:solidFill>
-          <a:ln>
-            <a:noFill/>
-          </a:ln>
-        </p:spPr>
-        <p:style>
-          <a:lnRef idx="1">
-            <a:schemeClr val="accent1"/>
-          </a:lnRef>
-          <a:fillRef idx="3">
-            <a:schemeClr val="accent1"/>
-          </a:fillRef>
-          <a:effectRef idx="2">
-            <a:schemeClr val="accent1"/>
-          </a:effectRef>
-          <a:fontRef idx="minor">
-            <a:schemeClr val="lt1"/>
-          </a:fontRef>
-        </p:style>
-        <p:txBody>
-          <a:bodyPr rtlCol="0" anchor="ctr"/>
-          <a:lstStyle/>
-          <a:p>
-            <a:pPr algn="ctr"/>
-          </a:p>
-        </p:txBody>
-      </p:sp>
-      <p:sp>
-        <p:nvSpPr>
-          <p:cNvPr id="128" name="P3 val"/>
-          <p:cNvSpPr txBox="1"/>
-          <p:nvPr/>
-        </p:nvSpPr>
-        <p:spPr>
-          <a:xfrm>
-            <a:off x="6035040" y="7543800"/>
-            <a:ext cx="822960" cy="502920"/>
-          </a:xfrm>
-          <a:prstGeom prst="rect">
-            <a:avLst/>
-          </a:prstGeom>
-          <a:noFill/>
-        </p:spPr>
-        <p:txBody>
-          <a:bodyPr wrap="square" anchor="ctr" lIns="45720" rIns="45720" tIns="18288" bIns="18288"/>
-          <a:lstStyle/>
-          <a:p>
-            <a:pPr algn="l"/>
-            <a:r>
-              <a:rPr sz="1300" b="1" i="0">
-                <a:solidFill>
-                  <a:srgbClr val="1E2761"/>
-                </a:solidFill>
-                <a:latin typeface="Calibri"/>
-              </a:rPr>
-              <a:t>63</a:t>
-            </a:r>
-          </a:p>
-        </p:txBody>
-      </p:sp>
-      <p:sp>
-        <p:nvSpPr>
-          <p:cNvPr id="129" name="P3 lbl"/>
-          <p:cNvSpPr txBox="1"/>
-          <p:nvPr/>
-        </p:nvSpPr>
-        <p:spPr>
-          <a:xfrm>
-            <a:off x="960120" y="8275320"/>
-            <a:ext cx="1554480" cy="502920"/>
-          </a:xfrm>
-          <a:prstGeom prst="rect">
-            <a:avLst/>
-          </a:prstGeom>
-          <a:noFill/>
-        </p:spPr>
-        <p:txBody>
-          <a:bodyPr wrap="square" anchor="ctr" lIns="45720" rIns="45720" tIns="18288" bIns="18288"/>
-          <a:lstStyle/>
-          <a:p>
-            <a:pPr algn="r"/>
-            <a:r>
-              <a:rPr sz="1300" b="0" i="0">
-                <a:solidFill>
-                  <a:srgbClr val="1E2761"/>
-                </a:solidFill>
-                <a:latin typeface="Calibri"/>
-              </a:rPr>
-              <a:t>DM-Count</a:t>
-            </a:r>
-          </a:p>
-        </p:txBody>
-      </p:sp>
-      <p:sp>
-        <p:nvSpPr>
-          <p:cNvPr id="130" name="P3 track"/>
-          <p:cNvSpPr/>
-          <p:nvPr/>
-        </p:nvSpPr>
-        <p:spPr>
-          <a:xfrm>
-            <a:off x="2606040" y="8366760"/>
-            <a:ext cx="3291840" cy="292608"/>
-          </a:xfrm>
-          <a:prstGeom prst="rect">
-            <a:avLst/>
-          </a:prstGeom>
-          <a:solidFill>
-            <a:srgbClr val="D5DBEA"/>
-          </a:solidFill>
-          <a:ln>
-            <a:noFill/>
-          </a:ln>
-        </p:spPr>
-        <p:style>
-          <a:lnRef idx="1">
-            <a:schemeClr val="accent1"/>
-          </a:lnRef>
-          <a:fillRef idx="3">
-            <a:schemeClr val="accent1"/>
-          </a:fillRef>
-          <a:effectRef idx="2">
-            <a:schemeClr val="accent1"/>
-          </a:effectRef>
-          <a:fontRef idx="minor">
-            <a:schemeClr val="lt1"/>
-          </a:fontRef>
-        </p:style>
-        <p:txBody>
-          <a:bodyPr rtlCol="0" anchor="ctr"/>
-          <a:lstStyle/>
-          <a:p>
-            <a:pPr algn="ctr"/>
-          </a:p>
-        </p:txBody>
-      </p:sp>
-      <p:sp>
-        <p:nvSpPr>
-          <p:cNvPr id="131" name="P3 fill"/>
-          <p:cNvSpPr/>
-          <p:nvPr/>
-        </p:nvSpPr>
-        <p:spPr>
-          <a:xfrm>
-            <a:off x="2606040" y="8366760"/>
-            <a:ext cx="2821577" cy="292608"/>
-          </a:xfrm>
-          <a:prstGeom prst="rect">
-            <a:avLst/>
-          </a:prstGeom>
-          <a:solidFill>
-            <a:srgbClr val="1E2761"/>
-          </a:solidFill>
-          <a:ln>
-            <a:noFill/>
-          </a:ln>
-        </p:spPr>
-        <p:style>
-          <a:lnRef idx="1">
-            <a:schemeClr val="accent1"/>
-          </a:lnRef>
-          <a:fillRef idx="3">
-            <a:schemeClr val="accent1"/>
-          </a:fillRef>
-          <a:effectRef idx="2">
-            <a:schemeClr val="accent1"/>
-          </a:effectRef>
-          <a:fontRef idx="minor">
-            <a:schemeClr val="lt1"/>
-          </a:fontRef>
-        </p:style>
-        <p:txBody>
-          <a:bodyPr rtlCol="0" anchor="ctr"/>
-          <a:lstStyle/>
-          <a:p>
-            <a:pPr algn="ctr"/>
-          </a:p>
-        </p:txBody>
-      </p:sp>
-      <p:sp>
-        <p:nvSpPr>
-          <p:cNvPr id="132" name="P3 val"/>
-          <p:cNvSpPr txBox="1"/>
-          <p:nvPr/>
-        </p:nvSpPr>
-        <p:spPr>
-          <a:xfrm>
-            <a:off x="6035040" y="8275320"/>
-            <a:ext cx="822960" cy="502920"/>
-          </a:xfrm>
-          <a:prstGeom prst="rect">
-            <a:avLst/>
-          </a:prstGeom>
-          <a:noFill/>
-        </p:spPr>
-        <p:txBody>
-          <a:bodyPr wrap="square" anchor="ctr" lIns="45720" rIns="45720" tIns="18288" bIns="18288"/>
-          <a:lstStyle/>
-          <a:p>
-            <a:pPr algn="l"/>
-            <a:r>
-              <a:rPr sz="1300" b="1" i="0">
-                <a:solidFill>
-                  <a:srgbClr val="1E2761"/>
-                </a:solidFill>
-                <a:latin typeface="Calibri"/>
-              </a:rPr>
-              <a:t>60</a:t>
-            </a:r>
-          </a:p>
-        </p:txBody>
-      </p:sp>
-      <p:sp>
-        <p:nvSpPr>
-          <p:cNvPr id="133" name="P3 lbl"/>
-          <p:cNvSpPr txBox="1"/>
-          <p:nvPr/>
-        </p:nvSpPr>
-        <p:spPr>
-          <a:xfrm>
-            <a:off x="960120" y="9006840"/>
-            <a:ext cx="1554480" cy="502920"/>
-          </a:xfrm>
-          <a:prstGeom prst="rect">
-            <a:avLst/>
-          </a:prstGeom>
-          <a:noFill/>
-        </p:spPr>
-        <p:txBody>
-          <a:bodyPr wrap="square" anchor="ctr" lIns="45720" rIns="45720" tIns="18288" bIns="18288"/>
-          <a:lstStyle/>
-          <a:p>
-            <a:pPr algn="r"/>
-            <a:r>
-              <a:rPr sz="1300" b="0" i="0">
-                <a:solidFill>
-                  <a:srgbClr val="1E2761"/>
-                </a:solidFill>
-                <a:latin typeface="Calibri"/>
-              </a:rPr>
-              <a:t>Latest</a:t>
-            </a:r>
-          </a:p>
-        </p:txBody>
-      </p:sp>
-      <p:sp>
-        <p:nvSpPr>
-          <p:cNvPr id="134" name="P3 track"/>
-          <p:cNvSpPr/>
-          <p:nvPr/>
-        </p:nvSpPr>
-        <p:spPr>
-          <a:xfrm>
-            <a:off x="2606040" y="9098280"/>
-            <a:ext cx="3291840" cy="292608"/>
-          </a:xfrm>
-          <a:prstGeom prst="rect">
-            <a:avLst/>
-          </a:prstGeom>
-          <a:solidFill>
-            <a:srgbClr val="D5DBEA"/>
-          </a:solidFill>
-          <a:ln>
-            <a:noFill/>
-          </a:ln>
-        </p:spPr>
-        <p:style>
-          <a:lnRef idx="1">
-            <a:schemeClr val="accent1"/>
-          </a:lnRef>
-          <a:fillRef idx="3">
-            <a:schemeClr val="accent1"/>
-          </a:fillRef>
-          <a:effectRef idx="2">
-            <a:schemeClr val="accent1"/>
-          </a:effectRef>
-          <a:fontRef idx="minor">
-            <a:schemeClr val="lt1"/>
-          </a:fontRef>
-        </p:style>
-        <p:txBody>
-          <a:bodyPr rtlCol="0" anchor="ctr"/>
-          <a:lstStyle/>
-          <a:p>
-            <a:pPr algn="ctr"/>
-          </a:p>
-        </p:txBody>
-      </p:sp>
-      <p:sp>
-        <p:nvSpPr>
-          <p:cNvPr id="135" name="P3 fill"/>
-          <p:cNvSpPr/>
-          <p:nvPr/>
-        </p:nvSpPr>
-        <p:spPr>
-          <a:xfrm>
-            <a:off x="2606040" y="9098280"/>
-            <a:ext cx="2304288" cy="292608"/>
-          </a:xfrm>
-          <a:prstGeom prst="rect">
-            <a:avLst/>
-          </a:prstGeom>
-          <a:solidFill>
-            <a:srgbClr val="1E2761"/>
-          </a:solidFill>
-          <a:ln>
-            <a:noFill/>
-          </a:ln>
-        </p:spPr>
-        <p:style>
-          <a:lnRef idx="1">
-            <a:schemeClr val="accent1"/>
-          </a:lnRef>
-          <a:fillRef idx="3">
-            <a:schemeClr val="accent1"/>
-          </a:fillRef>
-          <a:effectRef idx="2">
-            <a:schemeClr val="accent1"/>
-          </a:effectRef>
-          <a:fontRef idx="minor">
-            <a:schemeClr val="lt1"/>
-          </a:fontRef>
-        </p:style>
-        <p:txBody>
-          <a:bodyPr rtlCol="0" anchor="ctr"/>
-          <a:lstStyle/>
-          <a:p>
-            <a:pPr algn="ctr"/>
-          </a:p>
-        </p:txBody>
-      </p:sp>
-      <p:sp>
-        <p:nvSpPr>
-          <p:cNvPr id="136" name="P3 val"/>
-          <p:cNvSpPr txBox="1"/>
-          <p:nvPr/>
-        </p:nvSpPr>
-        <p:spPr>
-          <a:xfrm>
-            <a:off x="6035040" y="9006840"/>
-            <a:ext cx="822960" cy="502920"/>
-          </a:xfrm>
-          <a:prstGeom prst="rect">
-            <a:avLst/>
-          </a:prstGeom>
-          <a:noFill/>
-        </p:spPr>
-        <p:txBody>
-          <a:bodyPr wrap="square" anchor="ctr" lIns="45720" rIns="45720" tIns="18288" bIns="18288"/>
-          <a:lstStyle/>
-          <a:p>
-            <a:pPr algn="l"/>
-            <a:r>
-              <a:rPr sz="1300" b="1" i="0">
-                <a:solidFill>
-                  <a:srgbClr val="1E2761"/>
-                </a:solidFill>
-                <a:latin typeface="Calibri"/>
-              </a:rPr>
-              <a:t>49</a:t>
+              <a:rPr sz="1100" b="0" i="0">
+                <a:solidFill>
+                  <a:srgbClr val="111111"/>
+                </a:solidFill>
+                <a:latin typeface="Calibri"/>
+              </a:rPr>
+              <a:t>Flow field on our station clip (DIS optical flow). Movers glow, stillness stays black.</a:t>
             </a:r>
           </a:p>
         </p:txBody>
@@ -8114,13 +7686,13 @@
           <a:p>
             <a:pPr algn="l"/>
             <a:r>
-              <a:rPr sz="1500" b="0" i="0">
+              <a:rPr sz="1400" b="0" i="0">
                 <a:solidFill>
                   <a:srgbClr val="111111"/>
                 </a:solidFill>
                 <a:latin typeface="Calibri"/>
               </a:rPr>
-              <a:t>Fixed gates are measured once. Other views use relative levels. No fake square metres.</a:t>
+              <a:t>Fixed gates are measured once. Kumbh ran 3-month camera surveys for its crowd alarm. Other views use relative levels.</a:t>
             </a:r>
           </a:p>
         </p:txBody>
@@ -8818,54 +8390,48 @@
                 </a:solidFill>
                 <a:latin typeface="Calibri"/>
               </a:rPr>
-              <a:t>Runs on site, not in the cloud</a:t>
-            </a:r>
-          </a:p>
-        </p:txBody>
-      </p:sp>
-      <p:sp>
-        <p:nvSpPr>
-          <p:cNvPr id="121" name="P4 siterow"/>
-          <p:cNvSpPr txBox="1"/>
-          <p:nvPr/>
-        </p:nvSpPr>
-        <p:spPr>
-          <a:xfrm>
-            <a:off x="9601200" y="7424927"/>
-            <a:ext cx="7680960" cy="548640"/>
+              <a:t>Pressure warned first</a:t>
+            </a:r>
+          </a:p>
+        </p:txBody>
+      </p:sp>
+      <p:pic>
+        <p:nvPicPr>
+          <p:cNvPr id="121" name="P4 pressure" descr="pressure_strip.png"/>
+          <p:cNvPicPr>
+            <a:picLocks noChangeAspect="1"/>
+          </p:cNvPicPr>
+          <p:nvPr/>
+        </p:nvPicPr>
+        <p:blipFill>
+          <a:blip r:embed="rId4"/>
+          <a:stretch>
+            <a:fillRect/>
+          </a:stretch>
+        </p:blipFill>
+        <p:spPr>
+          <a:xfrm>
+            <a:off x="9601200" y="7360920"/>
+            <a:ext cx="4480560" cy="1938528"/>
           </a:xfrm>
           <a:prstGeom prst="rect">
             <a:avLst/>
           </a:prstGeom>
-          <a:noFill/>
-        </p:spPr>
-        <p:txBody>
-          <a:bodyPr wrap="square" anchor="ctr" lIns="45720" rIns="45720" tIns="18288" bIns="18288"/>
-          <a:lstStyle/>
-          <a:p>
-            <a:pPr algn="l"/>
-            <a:r>
-              <a:rPr sz="1350" b="0" i="0">
-                <a:solidFill>
-                  <a:srgbClr val="111111"/>
-                </a:solidFill>
-                <a:latin typeface="Calibri"/>
-              </a:rPr>
-              <a:t>Edge box per 1 to 4 cameras (Jetson class)</a:t>
-            </a:r>
-          </a:p>
-        </p:txBody>
-      </p:sp>
-      <p:sp>
-        <p:nvSpPr>
-          <p:cNvPr id="122" name="P4 siterow"/>
+          <a:ln>
+            <a:noFill/>
+          </a:ln>
+        </p:spPr>
+      </p:pic>
+      <p:sp>
+        <p:nvSpPr>
+          <p:cNvPr id="122" name="P4 pressurec"/>
           <p:cNvSpPr txBox="1"/>
           <p:nvPr/>
         </p:nvSpPr>
         <p:spPr>
           <a:xfrm>
-            <a:off x="9601200" y="7991855"/>
-            <a:ext cx="7680960" cy="548640"/>
+            <a:off x="14264640" y="7360920"/>
+            <a:ext cx="3017520" cy="1938528"/>
           </a:xfrm>
           <a:prstGeom prst="rect">
             <a:avLst/>
@@ -8878,79 +8444,13 @@
           <a:p>
             <a:pPr algn="l"/>
             <a:r>
-              <a:rPr sz="1350" b="0" i="0">
+              <a:rPr sz="1200" b="0" i="0">
                 <a:solidFill>
                   <a:srgbClr val="111111"/>
                 </a:solidFill>
                 <a:latin typeface="Calibri"/>
               </a:rPr>
-              <a:t>Venue server fuses every feed into one map</a:t>
-            </a:r>
-          </a:p>
-        </p:txBody>
-      </p:sp>
-      <p:sp>
-        <p:nvSpPr>
-          <p:cNvPr id="123" name="P4 siterow"/>
-          <p:cNvSpPr txBox="1"/>
-          <p:nvPr/>
-        </p:nvSpPr>
-        <p:spPr>
-          <a:xfrm>
-            <a:off x="9601200" y="8558784"/>
-            <a:ext cx="7680960" cy="548640"/>
-          </a:xfrm>
-          <a:prstGeom prst="rect">
-            <a:avLst/>
-          </a:prstGeom>
-          <a:noFill/>
-        </p:spPr>
-        <p:txBody>
-          <a:bodyPr wrap="square" anchor="ctr" lIns="45720" rIns="45720" tIns="18288" bIns="18288"/>
-          <a:lstStyle/>
-          <a:p>
-            <a:pPr algn="l"/>
-            <a:r>
-              <a:rPr sz="1350" b="0" i="0">
-                <a:solidFill>
-                  <a:srgbClr val="111111"/>
-                </a:solidFill>
-                <a:latin typeface="Calibri"/>
-              </a:rPr>
-              <a:t>Guard handsets get the alert, human confirms</a:t>
-            </a:r>
-          </a:p>
-        </p:txBody>
-      </p:sp>
-      <p:sp>
-        <p:nvSpPr>
-          <p:cNvPr id="124" name="P4 sitef"/>
-          <p:cNvSpPr txBox="1"/>
-          <p:nvPr/>
-        </p:nvSpPr>
-        <p:spPr>
-          <a:xfrm>
-            <a:off x="9601200" y="9125712"/>
-            <a:ext cx="7680960" cy="365760"/>
-          </a:xfrm>
-          <a:prstGeom prst="rect">
-            <a:avLst/>
-          </a:prstGeom>
-          <a:noFill/>
-        </p:spPr>
-        <p:txBody>
-          <a:bodyPr wrap="square" anchor="ctr" lIns="45720" rIns="45720" tIns="18288" bIns="18288"/>
-          <a:lstStyle/>
-          <a:p>
-            <a:pPr algn="l"/>
-            <a:r>
-              <a:rPr sz="1050" b="0" i="0">
-                <a:solidFill>
-                  <a:srgbClr val="5A5A5A"/>
-                </a:solidFill>
-                <a:latin typeface="Calibri"/>
-              </a:rPr>
-              <a:t>Deployment scale numbers only, no laptop tests.</a:t>
+              <a:t>Pressure crossed the warning line before turbulence began. The accident came after. Hajj 2006 data (Johansson et al.).</a:t>
             </a:r>
           </a:p>
         </p:txBody>
@@ -9258,9 +8758,7 @@
           </a:effectLst>
         </p:spPr>
         <p:txBody>
-          <a:bodyPr wrap="square" lIns="320040" tIns="109728" rIns="320040" bIns="109728" anchor="ctr" rtlCol="0">
-            <a:noAutofit/>
-          </a:bodyPr>
+          <a:bodyPr wrap="square" lIns="45720" tIns="18288" rIns="45720" bIns="18288" anchor="ctr" rtlCol="0"/>
           <a:lstStyle/>
           <a:p>
             <a:pPr algn="l">
@@ -9272,37 +8770,25 @@
               </a:spcAft>
             </a:pPr>
             <a:r>
-              <a:rPr lang="en-US" sz="2200" b="1" i="0" dirty="0">
+              <a:rPr sz="2000" b="1" i="0">
                 <a:solidFill>
                   <a:srgbClr val="1E2761"/>
                 </a:solidFill>
                 <a:latin typeface="Calibri"/>
-                <a:cs typeface="Calibri"/>
               </a:rPr>
               <a:t>Organizers</a:t>
             </a:r>
           </a:p>
           <a:p>
-            <a:pPr algn="l">
-              <a:lnSpc>
-                <a:spcPct val="100000"/>
-              </a:lnSpc>
-              <a:spcBef>
-                <a:spcPts val="0"/>
-              </a:spcBef>
-              <a:spcAft>
-                <a:spcPts val="0"/>
-              </a:spcAft>
-            </a:pPr>
-            <a:r>
-              <a:rPr lang="en-US" sz="1800" b="0" i="0" dirty="0">
+            <a:pPr algn="l"/>
+            <a:r>
+              <a:rPr sz="1500" b="0" i="0">
                 <a:solidFill>
                   <a:srgbClr val="111111"/>
                 </a:solidFill>
                 <a:latin typeface="Calibri"/>
-                <a:cs typeface="Calibri"/>
-              </a:rPr>
-              <a:t>Spot a growing jam early, and tell guards which zone to clear.</a:t>
+              </a:rPr>
+              <a:t>Spot a growing jam early, and tell guards which zone to clear. Built for stations, mela grounds, stadiums.</a:t>
             </a:r>
           </a:p>
         </p:txBody>
@@ -10065,382 +9551,6 @@
       </p:sp>
       <p:sp>
         <p:nvSpPr>
-          <p:cNvPr id="102" name="Card 102"/>
-          <p:cNvSpPr/>
-          <p:nvPr/>
-        </p:nvSpPr>
-        <p:spPr>
-          <a:xfrm>
-            <a:off x="731520" y="3108960"/>
-            <a:ext cx="8229600" cy="1554480"/>
-          </a:xfrm>
-          <a:prstGeom prst="roundRect">
-            <a:avLst>
-              <a:gd name="adj" fmla="val 9000"/>
-            </a:avLst>
-          </a:prstGeom>
-          <a:solidFill>
-            <a:srgbClr val="EEF2FF"/>
-          </a:solidFill>
-          <a:ln>
-            <a:noFill/>
-          </a:ln>
-          <a:effectLst>
-            <a:outerShdw blurRad="127000" dist="38100" dir="5400000" algn="t" rotWithShape="0">
-              <a:srgbClr val="1E2761">
-                <a:alpha val="16000"/>
-              </a:srgbClr>
-            </a:outerShdw>
-          </a:effectLst>
-        </p:spPr>
-        <p:txBody>
-          <a:bodyPr wrap="square" lIns="45720" tIns="18288" rIns="45720" bIns="18288" anchor="ctr" rtlCol="0"/>
-          <a:lstStyle/>
-          <a:p>
-            <a:pPr algn="l">
-              <a:spcBef>
-                <a:spcPts val="0"/>
-              </a:spcBef>
-              <a:spcAft>
-                <a:spcPts val="400"/>
-              </a:spcAft>
-            </a:pPr>
-            <a:r>
-              <a:rPr sz="1800" b="1" i="0">
-                <a:solidFill>
-                  <a:srgbClr val="1E2761"/>
-                </a:solidFill>
-                <a:latin typeface="Calibri"/>
-              </a:rPr>
-              <a:t>Count the overlap</a:t>
-            </a:r>
-          </a:p>
-          <a:p>
-            <a:pPr algn="l"/>
-            <a:r>
-              <a:rPr sz="1300" b="0" i="0">
-                <a:solidFill>
-                  <a:srgbClr val="111111"/>
-                </a:solidFill>
-                <a:latin typeface="Calibri"/>
-              </a:rPr>
-              <a:t>CSRNet (CVPR 2018), Bayesian Loss (ICCV 2019), DM-Count (NeurIPS 2020).</a:t>
-            </a:r>
-          </a:p>
-          <a:p>
-            <a:pPr algn="l"/>
-            <a:r>
-              <a:rPr sz="1100" b="0" i="0">
-                <a:solidFill>
-                  <a:srgbClr val="5A5A5A"/>
-                </a:solidFill>
-                <a:latin typeface="Calibri"/>
-                <a:hlinkClick r:id="rId9"/>
-              </a:rPr>
-              <a:t>arXiv:1802.10062  </a:t>
-            </a:r>
-            <a:r>
-              <a:rPr sz="1100" b="0" i="0">
-                <a:solidFill>
-                  <a:srgbClr val="5A5A5A"/>
-                </a:solidFill>
-                <a:latin typeface="Calibri"/>
-                <a:hlinkClick r:id="rId10"/>
-              </a:rPr>
-              <a:t>arXiv:1908.03684  </a:t>
-            </a:r>
-            <a:r>
-              <a:rPr sz="1100" b="0" i="0">
-                <a:solidFill>
-                  <a:srgbClr val="5A5A5A"/>
-                </a:solidFill>
-                <a:latin typeface="Calibri"/>
-                <a:hlinkClick r:id="rId11"/>
-              </a:rPr>
-              <a:t>DM-Count</a:t>
-            </a:r>
-          </a:p>
-        </p:txBody>
-      </p:sp>
-      <p:sp>
-        <p:nvSpPr>
-          <p:cNvPr id="103" name="Card 103"/>
-          <p:cNvSpPr/>
-          <p:nvPr/>
-        </p:nvSpPr>
-        <p:spPr>
-          <a:xfrm>
-            <a:off x="9326880" y="3108960"/>
-            <a:ext cx="8229600" cy="1554480"/>
-          </a:xfrm>
-          <a:prstGeom prst="roundRect">
-            <a:avLst>
-              <a:gd name="adj" fmla="val 9000"/>
-            </a:avLst>
-          </a:prstGeom>
-          <a:solidFill>
-            <a:srgbClr val="EEF2FF"/>
-          </a:solidFill>
-          <a:ln>
-            <a:noFill/>
-          </a:ln>
-          <a:effectLst>
-            <a:outerShdw blurRad="127000" dist="38100" dir="5400000" algn="t" rotWithShape="0">
-              <a:srgbClr val="1E2761">
-                <a:alpha val="16000"/>
-              </a:srgbClr>
-            </a:outerShdw>
-          </a:effectLst>
-        </p:spPr>
-        <p:txBody>
-          <a:bodyPr wrap="square" lIns="45720" tIns="18288" rIns="45720" bIns="18288" anchor="ctr" rtlCol="0"/>
-          <a:lstStyle/>
-          <a:p>
-            <a:pPr algn="l">
-              <a:spcBef>
-                <a:spcPts val="0"/>
-              </a:spcBef>
-              <a:spcAft>
-                <a:spcPts val="400"/>
-              </a:spcAft>
-            </a:pPr>
-            <a:r>
-              <a:rPr sz="1800" b="1" i="0">
-                <a:solidFill>
-                  <a:srgbClr val="1E2761"/>
-                </a:solidFill>
-                <a:latin typeface="Calibri"/>
-              </a:rPr>
-              <a:t>Map pixels to ground</a:t>
-            </a:r>
-          </a:p>
-          <a:p>
-            <a:pPr algn="l"/>
-            <a:r>
-              <a:rPr sz="1300" b="0" i="0">
-                <a:solidFill>
-                  <a:srgbClr val="111111"/>
-                </a:solidFill>
-                <a:latin typeface="Calibri"/>
-              </a:rPr>
-              <a:t>Chan perspective maps (CVPR 2008), Zhang ground-plane fusion (CVPR 2019).</a:t>
-            </a:r>
-          </a:p>
-          <a:p>
-            <a:pPr algn="l"/>
-            <a:r>
-              <a:rPr sz="1100" b="0" i="0">
-                <a:solidFill>
-                  <a:srgbClr val="5A5A5A"/>
-                </a:solidFill>
-                <a:latin typeface="Calibri"/>
-                <a:hlinkClick r:id="rId12"/>
-              </a:rPr>
-              <a:t>people counting paper  </a:t>
-            </a:r>
-            <a:r>
-              <a:rPr sz="1100" b="0" i="0">
-                <a:solidFill>
-                  <a:srgbClr val="5A5A5A"/>
-                </a:solidFill>
-                <a:latin typeface="Calibri"/>
-                <a:hlinkClick r:id="rId13"/>
-              </a:rPr>
-              <a:t>ground-plane paper</a:t>
-            </a:r>
-          </a:p>
-        </p:txBody>
-      </p:sp>
-      <p:sp>
-        <p:nvSpPr>
-          <p:cNvPr id="104" name="Card 104"/>
-          <p:cNvSpPr/>
-          <p:nvPr/>
-        </p:nvSpPr>
-        <p:spPr>
-          <a:xfrm>
-            <a:off x="731520" y="4800600"/>
-            <a:ext cx="8229600" cy="1554480"/>
-          </a:xfrm>
-          <a:prstGeom prst="roundRect">
-            <a:avLst>
-              <a:gd name="adj" fmla="val 9000"/>
-            </a:avLst>
-          </a:prstGeom>
-          <a:solidFill>
-            <a:srgbClr val="EEF2FF"/>
-          </a:solidFill>
-          <a:ln>
-            <a:noFill/>
-          </a:ln>
-          <a:effectLst>
-            <a:outerShdw blurRad="127000" dist="38100" dir="5400000" algn="t" rotWithShape="0">
-              <a:srgbClr val="1E2761">
-                <a:alpha val="16000"/>
-              </a:srgbClr>
-            </a:outerShdw>
-          </a:effectLst>
-        </p:spPr>
-        <p:txBody>
-          <a:bodyPr wrap="square" lIns="45720" tIns="18288" rIns="45720" bIns="18288" anchor="ctr" rtlCol="0"/>
-          <a:lstStyle/>
-          <a:p>
-            <a:pPr algn="l">
-              <a:spcBef>
-                <a:spcPts val="0"/>
-              </a:spcBef>
-              <a:spcAft>
-                <a:spcPts val="400"/>
-              </a:spcAft>
-            </a:pPr>
-            <a:r>
-              <a:rPr sz="1800" b="1" i="0">
-                <a:solidFill>
-                  <a:srgbClr val="1E2761"/>
-                </a:solidFill>
-                <a:latin typeface="Calibri"/>
-              </a:rPr>
-              <a:t>Read the currents</a:t>
-            </a:r>
-          </a:p>
-          <a:p>
-            <a:pPr algn="l"/>
-            <a:r>
-              <a:rPr sz="1300" b="0" i="0">
-                <a:solidFill>
-                  <a:srgbClr val="111111"/>
-                </a:solidFill>
-                <a:latin typeface="Calibri"/>
-              </a:rPr>
-              <a:t>Mehran social force (CVPR 2009), streaklines (ECCV 2010).</a:t>
-            </a:r>
-          </a:p>
-          <a:p>
-            <a:pPr algn="l"/>
-            <a:r>
-              <a:rPr sz="1100" b="0" i="0">
-                <a:solidFill>
-                  <a:srgbClr val="5A5A5A"/>
-                </a:solidFill>
-                <a:latin typeface="Calibri"/>
-                <a:hlinkClick r:id="rId14"/>
-              </a:rPr>
-              <a:t>CVPR 2009 pdf  </a:t>
-            </a:r>
-            <a:r>
-              <a:rPr sz="1100" b="0" i="0">
-                <a:solidFill>
-                  <a:srgbClr val="5A5A5A"/>
-                </a:solidFill>
-                <a:latin typeface="Calibri"/>
-                <a:hlinkClick r:id="rId15"/>
-              </a:rPr>
-              <a:t>streakline project</a:t>
-            </a:r>
-          </a:p>
-        </p:txBody>
-      </p:sp>
-      <p:sp>
-        <p:nvSpPr>
-          <p:cNvPr id="105" name="Card 105"/>
-          <p:cNvSpPr/>
-          <p:nvPr/>
-        </p:nvSpPr>
-        <p:spPr>
-          <a:xfrm>
-            <a:off x="9326880" y="4800600"/>
-            <a:ext cx="8229600" cy="1554480"/>
-          </a:xfrm>
-          <a:prstGeom prst="roundRect">
-            <a:avLst>
-              <a:gd name="adj" fmla="val 9000"/>
-            </a:avLst>
-          </a:prstGeom>
-          <a:solidFill>
-            <a:srgbClr val="EEF2FF"/>
-          </a:solidFill>
-          <a:ln>
-            <a:noFill/>
-          </a:ln>
-          <a:effectLst>
-            <a:outerShdw blurRad="127000" dist="38100" dir="5400000" algn="t" rotWithShape="0">
-              <a:srgbClr val="1E2761">
-                <a:alpha val="16000"/>
-              </a:srgbClr>
-            </a:outerShdw>
-          </a:effectLst>
-        </p:spPr>
-        <p:txBody>
-          <a:bodyPr wrap="square" lIns="45720" tIns="18288" rIns="45720" bIns="18288" anchor="ctr" rtlCol="0"/>
-          <a:lstStyle/>
-          <a:p>
-            <a:pPr algn="l">
-              <a:spcBef>
-                <a:spcPts val="0"/>
-              </a:spcBef>
-              <a:spcAft>
-                <a:spcPts val="400"/>
-              </a:spcAft>
-            </a:pPr>
-            <a:r>
-              <a:rPr sz="1800" b="1" i="0">
-                <a:solidFill>
-                  <a:srgbClr val="1E2761"/>
-                </a:solidFill>
-                <a:latin typeface="Calibri"/>
-              </a:rPr>
-              <a:t>Warn on pressure</a:t>
-            </a:r>
-          </a:p>
-          <a:p>
-            <a:pPr algn="l"/>
-            <a:r>
-              <a:rPr sz="1300" b="0" i="0">
-                <a:solidFill>
-                  <a:srgbClr val="111111"/>
-                </a:solidFill>
-                <a:latin typeface="Calibri"/>
-              </a:rPr>
-              <a:t>Helbing social force (1995), crowd disasters (2007), Johansson pressure (2008).</a:t>
-            </a:r>
-          </a:p>
-          <a:p>
-            <a:pPr algn="l"/>
-            <a:r>
-              <a:rPr sz="1100" b="0" i="0">
-                <a:solidFill>
-                  <a:srgbClr val="5A5A5A"/>
-                </a:solidFill>
-                <a:latin typeface="Calibri"/>
-                <a:hlinkClick r:id="rId16"/>
-              </a:rPr>
-              <a:t>DOI:10.1103/PhysRevE.51.4282  </a:t>
-            </a:r>
-            <a:r>
-              <a:rPr sz="1100" b="0" i="0">
-                <a:solidFill>
-                  <a:srgbClr val="5A5A5A"/>
-                </a:solidFill>
-                <a:latin typeface="Calibri"/>
-                <a:hlinkClick r:id="rId17"/>
-              </a:rPr>
-              <a:t>arXiv:0708.3339  </a:t>
-            </a:r>
-            <a:r>
-              <a:rPr sz="1100" b="0" i="0">
-                <a:solidFill>
-                  <a:srgbClr val="5A5A5A"/>
-                </a:solidFill>
-                <a:latin typeface="Calibri"/>
-                <a:hlinkClick r:id="rId18"/>
-              </a:rPr>
-              <a:t>pressure analysis</a:t>
-            </a:r>
-          </a:p>
-        </p:txBody>
-      </p:sp>
-      <p:sp>
-        <p:nvSpPr>
           <p:cNvPr id="106" name="TextBox 106"/>
           <p:cNvSpPr txBox="1"/>
           <p:nvPr/>
@@ -10801,6 +9911,789 @@
                 <a:cs typeface="Calibri"/>
               </a:rPr>
               <a:t>Team Raksha  |  Team Leader: Shounak Joshi</a:t>
+            </a:r>
+          </a:p>
+        </p:txBody>
+      </p:sp>
+      <p:sp>
+        <p:nvSpPr>
+          <p:cNvPr id="112" name="R6 colh"/>
+          <p:cNvSpPr txBox="1"/>
+          <p:nvPr/>
+        </p:nvSpPr>
+        <p:spPr>
+          <a:xfrm>
+            <a:off x="731520" y="3017520"/>
+            <a:ext cx="5120640" cy="384048"/>
+          </a:xfrm>
+          <a:prstGeom prst="rect">
+            <a:avLst/>
+          </a:prstGeom>
+          <a:noFill/>
+        </p:spPr>
+        <p:txBody>
+          <a:bodyPr wrap="square" anchor="ctr" lIns="45720" rIns="45720" tIns="18288" bIns="18288"/>
+          <a:lstStyle/>
+          <a:p>
+            <a:pPr algn="l"/>
+            <a:r>
+              <a:rPr sz="1300" b="1" i="0">
+                <a:solidFill>
+                  <a:srgbClr val="1E2761"/>
+                </a:solidFill>
+                <a:latin typeface="Calibri"/>
+              </a:rPr>
+              <a:t>Count the overlap</a:t>
+            </a:r>
+          </a:p>
+        </p:txBody>
+      </p:sp>
+      <p:sp>
+        <p:nvSpPr>
+          <p:cNvPr id="113" name="R6 row"/>
+          <p:cNvSpPr txBox="1"/>
+          <p:nvPr/>
+        </p:nvSpPr>
+        <p:spPr>
+          <a:xfrm>
+            <a:off x="731520" y="3456432"/>
+            <a:ext cx="5120640" cy="384048"/>
+          </a:xfrm>
+          <a:prstGeom prst="rect">
+            <a:avLst/>
+          </a:prstGeom>
+          <a:noFill/>
+        </p:spPr>
+        <p:txBody>
+          <a:bodyPr wrap="square" anchor="ctr" lIns="45720" rIns="45720" tIns="18288" bIns="18288"/>
+          <a:lstStyle/>
+          <a:p>
+            <a:pPr algn="l"/>
+            <a:r>
+              <a:rPr sz="1050" b="0" i="0">
+                <a:solidFill>
+                  <a:srgbClr val="5A5A5A"/>
+                </a:solidFill>
+                <a:latin typeface="Calibri"/>
+                <a:hlinkClick r:id="rId9"/>
+              </a:rPr>
+              <a:t>CSRNet, CVPR 2018</a:t>
+            </a:r>
+          </a:p>
+        </p:txBody>
+      </p:sp>
+      <p:sp>
+        <p:nvSpPr>
+          <p:cNvPr id="114" name="R6 row"/>
+          <p:cNvSpPr txBox="1"/>
+          <p:nvPr/>
+        </p:nvSpPr>
+        <p:spPr>
+          <a:xfrm>
+            <a:off x="731520" y="3867911"/>
+            <a:ext cx="5120640" cy="384048"/>
+          </a:xfrm>
+          <a:prstGeom prst="rect">
+            <a:avLst/>
+          </a:prstGeom>
+          <a:noFill/>
+        </p:spPr>
+        <p:txBody>
+          <a:bodyPr wrap="square" anchor="ctr" lIns="45720" rIns="45720" tIns="18288" bIns="18288"/>
+          <a:lstStyle/>
+          <a:p>
+            <a:pPr algn="l"/>
+            <a:r>
+              <a:rPr sz="1050" b="0" i="0">
+                <a:solidFill>
+                  <a:srgbClr val="5A5A5A"/>
+                </a:solidFill>
+                <a:latin typeface="Calibri"/>
+                <a:hlinkClick r:id="rId10"/>
+              </a:rPr>
+              <a:t>Bayesian Loss, ICCV 2019</a:t>
+            </a:r>
+          </a:p>
+        </p:txBody>
+      </p:sp>
+      <p:sp>
+        <p:nvSpPr>
+          <p:cNvPr id="115" name="R6 row"/>
+          <p:cNvSpPr txBox="1"/>
+          <p:nvPr/>
+        </p:nvSpPr>
+        <p:spPr>
+          <a:xfrm>
+            <a:off x="731520" y="4279392"/>
+            <a:ext cx="5120640" cy="384048"/>
+          </a:xfrm>
+          <a:prstGeom prst="rect">
+            <a:avLst/>
+          </a:prstGeom>
+          <a:noFill/>
+        </p:spPr>
+        <p:txBody>
+          <a:bodyPr wrap="square" anchor="ctr" lIns="45720" rIns="45720" tIns="18288" bIns="18288"/>
+          <a:lstStyle/>
+          <a:p>
+            <a:pPr algn="l"/>
+            <a:r>
+              <a:rPr sz="1050" b="0" i="0">
+                <a:solidFill>
+                  <a:srgbClr val="5A5A5A"/>
+                </a:solidFill>
+                <a:latin typeface="Calibri"/>
+                <a:hlinkClick r:id="rId11"/>
+              </a:rPr>
+              <a:t>DM-Count, NeurIPS 2020</a:t>
+            </a:r>
+          </a:p>
+        </p:txBody>
+      </p:sp>
+      <p:sp>
+        <p:nvSpPr>
+          <p:cNvPr id="116" name="R6 row"/>
+          <p:cNvSpPr txBox="1"/>
+          <p:nvPr/>
+        </p:nvSpPr>
+        <p:spPr>
+          <a:xfrm>
+            <a:off x="731520" y="4690872"/>
+            <a:ext cx="5120640" cy="384048"/>
+          </a:xfrm>
+          <a:prstGeom prst="rect">
+            <a:avLst/>
+          </a:prstGeom>
+          <a:noFill/>
+        </p:spPr>
+        <p:txBody>
+          <a:bodyPr wrap="square" anchor="ctr" lIns="45720" rIns="45720" tIns="18288" bIns="18288"/>
+          <a:lstStyle/>
+          <a:p>
+            <a:pPr algn="l"/>
+            <a:r>
+              <a:rPr sz="1050" b="0" i="0">
+                <a:solidFill>
+                  <a:srgbClr val="5A5A5A"/>
+                </a:solidFill>
+                <a:latin typeface="Calibri"/>
+                <a:hlinkClick r:id="rId20"/>
+              </a:rPr>
+              <a:t>P2PNet, ICCV 2021</a:t>
+            </a:r>
+          </a:p>
+        </p:txBody>
+      </p:sp>
+      <p:sp>
+        <p:nvSpPr>
+          <p:cNvPr id="117" name="R6 row"/>
+          <p:cNvSpPr txBox="1"/>
+          <p:nvPr/>
+        </p:nvSpPr>
+        <p:spPr>
+          <a:xfrm>
+            <a:off x="731520" y="5102352"/>
+            <a:ext cx="5120640" cy="384048"/>
+          </a:xfrm>
+          <a:prstGeom prst="rect">
+            <a:avLst/>
+          </a:prstGeom>
+          <a:noFill/>
+        </p:spPr>
+        <p:txBody>
+          <a:bodyPr wrap="square" anchor="ctr" lIns="45720" rIns="45720" tIns="18288" bIns="18288"/>
+          <a:lstStyle/>
+          <a:p>
+            <a:pPr algn="l"/>
+            <a:r>
+              <a:rPr sz="1050" b="0" i="0">
+                <a:solidFill>
+                  <a:srgbClr val="5A5A5A"/>
+                </a:solidFill>
+                <a:latin typeface="Calibri"/>
+                <a:hlinkClick r:id="rId21"/>
+              </a:rPr>
+              <a:t>STEERER / APGCC, 2023-24</a:t>
+            </a:r>
+          </a:p>
+        </p:txBody>
+      </p:sp>
+      <p:sp>
+        <p:nvSpPr>
+          <p:cNvPr id="118" name="R6 row"/>
+          <p:cNvSpPr txBox="1"/>
+          <p:nvPr/>
+        </p:nvSpPr>
+        <p:spPr>
+          <a:xfrm>
+            <a:off x="731520" y="5513831"/>
+            <a:ext cx="5120640" cy="384048"/>
+          </a:xfrm>
+          <a:prstGeom prst="rect">
+            <a:avLst/>
+          </a:prstGeom>
+          <a:noFill/>
+        </p:spPr>
+        <p:txBody>
+          <a:bodyPr wrap="square" anchor="ctr" lIns="45720" rIns="45720" tIns="18288" bIns="18288"/>
+          <a:lstStyle/>
+          <a:p>
+            <a:pPr algn="l"/>
+            <a:r>
+              <a:rPr sz="1050" b="0" i="0">
+                <a:solidFill>
+                  <a:srgbClr val="5A5A5A"/>
+                </a:solidFill>
+                <a:latin typeface="Calibri"/>
+              </a:rPr>
+              <a:t>Tests: ShanghaiTech, QNRF, NWPU</a:t>
+            </a:r>
+          </a:p>
+        </p:txBody>
+      </p:sp>
+      <p:sp>
+        <p:nvSpPr>
+          <p:cNvPr id="119" name="R6 colh"/>
+          <p:cNvSpPr txBox="1"/>
+          <p:nvPr/>
+        </p:nvSpPr>
+        <p:spPr>
+          <a:xfrm>
+            <a:off x="6400800" y="3017520"/>
+            <a:ext cx="5120640" cy="384048"/>
+          </a:xfrm>
+          <a:prstGeom prst="rect">
+            <a:avLst/>
+          </a:prstGeom>
+          <a:noFill/>
+        </p:spPr>
+        <p:txBody>
+          <a:bodyPr wrap="square" anchor="ctr" lIns="45720" rIns="45720" tIns="18288" bIns="18288"/>
+          <a:lstStyle/>
+          <a:p>
+            <a:pPr algn="l"/>
+            <a:r>
+              <a:rPr sz="1300" b="1" i="0">
+                <a:solidFill>
+                  <a:srgbClr val="1E2761"/>
+                </a:solidFill>
+                <a:latin typeface="Calibri"/>
+              </a:rPr>
+              <a:t>Ground and currents</a:t>
+            </a:r>
+          </a:p>
+        </p:txBody>
+      </p:sp>
+      <p:sp>
+        <p:nvSpPr>
+          <p:cNvPr id="120" name="R6 row"/>
+          <p:cNvSpPr txBox="1"/>
+          <p:nvPr/>
+        </p:nvSpPr>
+        <p:spPr>
+          <a:xfrm>
+            <a:off x="6400800" y="3456432"/>
+            <a:ext cx="5120640" cy="384048"/>
+          </a:xfrm>
+          <a:prstGeom prst="rect">
+            <a:avLst/>
+          </a:prstGeom>
+          <a:noFill/>
+        </p:spPr>
+        <p:txBody>
+          <a:bodyPr wrap="square" anchor="ctr" lIns="45720" rIns="45720" tIns="18288" bIns="18288"/>
+          <a:lstStyle/>
+          <a:p>
+            <a:pPr algn="l"/>
+            <a:r>
+              <a:rPr sz="1050" b="0" i="0">
+                <a:solidFill>
+                  <a:srgbClr val="5A5A5A"/>
+                </a:solidFill>
+                <a:latin typeface="Calibri"/>
+                <a:hlinkClick r:id="rId12"/>
+              </a:rPr>
+              <a:t>Chan perspective maps, CVPR 2008</a:t>
+            </a:r>
+          </a:p>
+        </p:txBody>
+      </p:sp>
+      <p:sp>
+        <p:nvSpPr>
+          <p:cNvPr id="121" name="R6 row"/>
+          <p:cNvSpPr txBox="1"/>
+          <p:nvPr/>
+        </p:nvSpPr>
+        <p:spPr>
+          <a:xfrm>
+            <a:off x="6400800" y="3867911"/>
+            <a:ext cx="5120640" cy="384048"/>
+          </a:xfrm>
+          <a:prstGeom prst="rect">
+            <a:avLst/>
+          </a:prstGeom>
+          <a:noFill/>
+        </p:spPr>
+        <p:txBody>
+          <a:bodyPr wrap="square" anchor="ctr" lIns="45720" rIns="45720" tIns="18288" bIns="18288"/>
+          <a:lstStyle/>
+          <a:p>
+            <a:pPr algn="l"/>
+            <a:r>
+              <a:rPr sz="1050" b="0" i="0">
+                <a:solidFill>
+                  <a:srgbClr val="5A5A5A"/>
+                </a:solidFill>
+                <a:latin typeface="Calibri"/>
+                <a:hlinkClick r:id="rId13"/>
+              </a:rPr>
+              <a:t>Zhang ground-plane fusion, CVPR 2019</a:t>
+            </a:r>
+          </a:p>
+        </p:txBody>
+      </p:sp>
+      <p:sp>
+        <p:nvSpPr>
+          <p:cNvPr id="122" name="R6 row"/>
+          <p:cNvSpPr txBox="1"/>
+          <p:nvPr/>
+        </p:nvSpPr>
+        <p:spPr>
+          <a:xfrm>
+            <a:off x="6400800" y="4279392"/>
+            <a:ext cx="5120640" cy="384048"/>
+          </a:xfrm>
+          <a:prstGeom prst="rect">
+            <a:avLst/>
+          </a:prstGeom>
+          <a:noFill/>
+        </p:spPr>
+        <p:txBody>
+          <a:bodyPr wrap="square" anchor="ctr" lIns="45720" rIns="45720" tIns="18288" bIns="18288"/>
+          <a:lstStyle/>
+          <a:p>
+            <a:pPr algn="l"/>
+            <a:r>
+              <a:rPr sz="1050" b="0" i="0">
+                <a:solidFill>
+                  <a:srgbClr val="5A5A5A"/>
+                </a:solidFill>
+                <a:latin typeface="Calibri"/>
+                <a:hlinkClick r:id="rId22"/>
+              </a:rPr>
+              <a:t>PACNN perspective, CVPR 2019</a:t>
+            </a:r>
+          </a:p>
+        </p:txBody>
+      </p:sp>
+      <p:sp>
+        <p:nvSpPr>
+          <p:cNvPr id="123" name="R6 row"/>
+          <p:cNvSpPr txBox="1"/>
+          <p:nvPr/>
+        </p:nvSpPr>
+        <p:spPr>
+          <a:xfrm>
+            <a:off x="6400800" y="4690872"/>
+            <a:ext cx="5120640" cy="384048"/>
+          </a:xfrm>
+          <a:prstGeom prst="rect">
+            <a:avLst/>
+          </a:prstGeom>
+          <a:noFill/>
+        </p:spPr>
+        <p:txBody>
+          <a:bodyPr wrap="square" anchor="ctr" lIns="45720" rIns="45720" tIns="18288" bIns="18288"/>
+          <a:lstStyle/>
+          <a:p>
+            <a:pPr algn="l"/>
+            <a:r>
+              <a:rPr sz="1050" b="0" i="0">
+                <a:solidFill>
+                  <a:srgbClr val="5A5A5A"/>
+                </a:solidFill>
+                <a:latin typeface="Calibri"/>
+                <a:hlinkClick r:id="rId14"/>
+              </a:rPr>
+              <a:t>Mehran social force, CVPR 2009</a:t>
+            </a:r>
+          </a:p>
+        </p:txBody>
+      </p:sp>
+      <p:sp>
+        <p:nvSpPr>
+          <p:cNvPr id="124" name="R6 row"/>
+          <p:cNvSpPr txBox="1"/>
+          <p:nvPr/>
+        </p:nvSpPr>
+        <p:spPr>
+          <a:xfrm>
+            <a:off x="6400800" y="5102352"/>
+            <a:ext cx="5120640" cy="384048"/>
+          </a:xfrm>
+          <a:prstGeom prst="rect">
+            <a:avLst/>
+          </a:prstGeom>
+          <a:noFill/>
+        </p:spPr>
+        <p:txBody>
+          <a:bodyPr wrap="square" anchor="ctr" lIns="45720" rIns="45720" tIns="18288" bIns="18288"/>
+          <a:lstStyle/>
+          <a:p>
+            <a:pPr algn="l"/>
+            <a:r>
+              <a:rPr sz="1050" b="0" i="0">
+                <a:solidFill>
+                  <a:srgbClr val="5A5A5A"/>
+                </a:solidFill>
+                <a:latin typeface="Calibri"/>
+                <a:hlinkClick r:id="rId15"/>
+              </a:rPr>
+              <a:t>Mehran streaklines, ECCV 2010</a:t>
+            </a:r>
+          </a:p>
+        </p:txBody>
+      </p:sp>
+      <p:sp>
+        <p:nvSpPr>
+          <p:cNvPr id="125" name="R6 row"/>
+          <p:cNvSpPr txBox="1"/>
+          <p:nvPr/>
+        </p:nvSpPr>
+        <p:spPr>
+          <a:xfrm>
+            <a:off x="6400800" y="5513831"/>
+            <a:ext cx="5120640" cy="384048"/>
+          </a:xfrm>
+          <a:prstGeom prst="rect">
+            <a:avLst/>
+          </a:prstGeom>
+          <a:noFill/>
+        </p:spPr>
+        <p:txBody>
+          <a:bodyPr wrap="square" anchor="ctr" lIns="45720" rIns="45720" tIns="18288" bIns="18288"/>
+          <a:lstStyle/>
+          <a:p>
+            <a:pPr algn="l"/>
+            <a:r>
+              <a:rPr sz="1050" b="0" i="0">
+                <a:solidFill>
+                  <a:srgbClr val="5A5A5A"/>
+                </a:solidFill>
+                <a:latin typeface="Calibri"/>
+                <a:hlinkClick r:id="rId23"/>
+              </a:rPr>
+              <a:t>DIS optical flow (OpenCV)</a:t>
+            </a:r>
+          </a:p>
+        </p:txBody>
+      </p:sp>
+      <p:sp>
+        <p:nvSpPr>
+          <p:cNvPr id="126" name="R6 colh"/>
+          <p:cNvSpPr txBox="1"/>
+          <p:nvPr/>
+        </p:nvSpPr>
+        <p:spPr>
+          <a:xfrm>
+            <a:off x="12070080" y="3017520"/>
+            <a:ext cx="5120640" cy="384048"/>
+          </a:xfrm>
+          <a:prstGeom prst="rect">
+            <a:avLst/>
+          </a:prstGeom>
+          <a:noFill/>
+        </p:spPr>
+        <p:txBody>
+          <a:bodyPr wrap="square" anchor="ctr" lIns="45720" rIns="45720" tIns="18288" bIns="18288"/>
+          <a:lstStyle/>
+          <a:p>
+            <a:pPr algn="l"/>
+            <a:r>
+              <a:rPr sz="1300" b="1" i="0">
+                <a:solidFill>
+                  <a:srgbClr val="1E2761"/>
+                </a:solidFill>
+                <a:latin typeface="Calibri"/>
+              </a:rPr>
+              <a:t>Pressure and risk</a:t>
+            </a:r>
+          </a:p>
+        </p:txBody>
+      </p:sp>
+      <p:sp>
+        <p:nvSpPr>
+          <p:cNvPr id="127" name="R6 row"/>
+          <p:cNvSpPr txBox="1"/>
+          <p:nvPr/>
+        </p:nvSpPr>
+        <p:spPr>
+          <a:xfrm>
+            <a:off x="12070080" y="3456432"/>
+            <a:ext cx="5120640" cy="384048"/>
+          </a:xfrm>
+          <a:prstGeom prst="rect">
+            <a:avLst/>
+          </a:prstGeom>
+          <a:noFill/>
+        </p:spPr>
+        <p:txBody>
+          <a:bodyPr wrap="square" anchor="ctr" lIns="45720" rIns="45720" tIns="18288" bIns="18288"/>
+          <a:lstStyle/>
+          <a:p>
+            <a:pPr algn="l"/>
+            <a:r>
+              <a:rPr sz="1050" b="0" i="0">
+                <a:solidFill>
+                  <a:srgbClr val="5A5A5A"/>
+                </a:solidFill>
+                <a:latin typeface="Calibri"/>
+                <a:hlinkClick r:id="rId16"/>
+              </a:rPr>
+              <a:t>Helbing social force, 1995</a:t>
+            </a:r>
+          </a:p>
+        </p:txBody>
+      </p:sp>
+      <p:sp>
+        <p:nvSpPr>
+          <p:cNvPr id="128" name="R6 row"/>
+          <p:cNvSpPr txBox="1"/>
+          <p:nvPr/>
+        </p:nvSpPr>
+        <p:spPr>
+          <a:xfrm>
+            <a:off x="12070080" y="3867911"/>
+            <a:ext cx="5120640" cy="384048"/>
+          </a:xfrm>
+          <a:prstGeom prst="rect">
+            <a:avLst/>
+          </a:prstGeom>
+          <a:noFill/>
+        </p:spPr>
+        <p:txBody>
+          <a:bodyPr wrap="square" anchor="ctr" lIns="45720" rIns="45720" tIns="18288" bIns="18288"/>
+          <a:lstStyle/>
+          <a:p>
+            <a:pPr algn="l"/>
+            <a:r>
+              <a:rPr sz="1050" b="0" i="0">
+                <a:solidFill>
+                  <a:srgbClr val="5A5A5A"/>
+                </a:solidFill>
+                <a:latin typeface="Calibri"/>
+                <a:hlinkClick r:id="rId17"/>
+              </a:rPr>
+              <a:t>Helbing crowd disasters, 2007</a:t>
+            </a:r>
+          </a:p>
+        </p:txBody>
+      </p:sp>
+      <p:sp>
+        <p:nvSpPr>
+          <p:cNvPr id="129" name="R6 row"/>
+          <p:cNvSpPr txBox="1"/>
+          <p:nvPr/>
+        </p:nvSpPr>
+        <p:spPr>
+          <a:xfrm>
+            <a:off x="12070080" y="4279392"/>
+            <a:ext cx="5120640" cy="384048"/>
+          </a:xfrm>
+          <a:prstGeom prst="rect">
+            <a:avLst/>
+          </a:prstGeom>
+          <a:noFill/>
+        </p:spPr>
+        <p:txBody>
+          <a:bodyPr wrap="square" anchor="ctr" lIns="45720" rIns="45720" tIns="18288" bIns="18288"/>
+          <a:lstStyle/>
+          <a:p>
+            <a:pPr algn="l"/>
+            <a:r>
+              <a:rPr sz="1050" b="0" i="0">
+                <a:solidFill>
+                  <a:srgbClr val="5A5A5A"/>
+                </a:solidFill>
+                <a:latin typeface="Calibri"/>
+                <a:hlinkClick r:id="rId18"/>
+              </a:rPr>
+              <a:t>Johansson pressure, 2008</a:t>
+            </a:r>
+          </a:p>
+        </p:txBody>
+      </p:sp>
+      <p:sp>
+        <p:nvSpPr>
+          <p:cNvPr id="130" name="R6 row"/>
+          <p:cNvSpPr txBox="1"/>
+          <p:nvPr/>
+        </p:nvSpPr>
+        <p:spPr>
+          <a:xfrm>
+            <a:off x="12070080" y="4690872"/>
+            <a:ext cx="5120640" cy="384048"/>
+          </a:xfrm>
+          <a:prstGeom prst="rect">
+            <a:avLst/>
+          </a:prstGeom>
+          <a:noFill/>
+        </p:spPr>
+        <p:txBody>
+          <a:bodyPr wrap="square" anchor="ctr" lIns="45720" rIns="45720" tIns="18288" bIns="18288"/>
+          <a:lstStyle/>
+          <a:p>
+            <a:pPr algn="l"/>
+            <a:r>
+              <a:rPr sz="1050" b="0" i="0">
+                <a:solidFill>
+                  <a:srgbClr val="5A5A5A"/>
+                </a:solidFill>
+                <a:latin typeface="Calibri"/>
+                <a:hlinkClick r:id="rId24"/>
+              </a:rPr>
+              <a:t>Hughes continuum, 2002</a:t>
+            </a:r>
+          </a:p>
+        </p:txBody>
+      </p:sp>
+      <p:sp>
+        <p:nvSpPr>
+          <p:cNvPr id="131" name="R6 row"/>
+          <p:cNvSpPr txBox="1"/>
+          <p:nvPr/>
+        </p:nvSpPr>
+        <p:spPr>
+          <a:xfrm>
+            <a:off x="12070080" y="5102352"/>
+            <a:ext cx="5120640" cy="384048"/>
+          </a:xfrm>
+          <a:prstGeom prst="rect">
+            <a:avLst/>
+          </a:prstGeom>
+          <a:noFill/>
+        </p:spPr>
+        <p:txBody>
+          <a:bodyPr wrap="square" anchor="ctr" lIns="45720" rIns="45720" tIns="18288" bIns="18288"/>
+          <a:lstStyle/>
+          <a:p>
+            <a:pPr algn="l"/>
+            <a:r>
+              <a:rPr sz="1050" b="0" i="0">
+                <a:solidFill>
+                  <a:srgbClr val="5A5A5A"/>
+                </a:solidFill>
+                <a:latin typeface="Calibri"/>
+                <a:hlinkClick r:id="rId25"/>
+              </a:rPr>
+              <a:t>Nakayama divergence, BMVC 2025</a:t>
+            </a:r>
+          </a:p>
+        </p:txBody>
+      </p:sp>
+      <p:sp>
+        <p:nvSpPr>
+          <p:cNvPr id="132" name="R6 row"/>
+          <p:cNvSpPr txBox="1"/>
+          <p:nvPr/>
+        </p:nvSpPr>
+        <p:spPr>
+          <a:xfrm>
+            <a:off x="12070080" y="5513831"/>
+            <a:ext cx="5120640" cy="384048"/>
+          </a:xfrm>
+          <a:prstGeom prst="rect">
+            <a:avLst/>
+          </a:prstGeom>
+          <a:noFill/>
+        </p:spPr>
+        <p:txBody>
+          <a:bodyPr wrap="square" anchor="ctr" lIns="45720" rIns="45720" tIns="18288" bIns="18288"/>
+          <a:lstStyle/>
+          <a:p>
+            <a:pPr algn="l"/>
+            <a:r>
+              <a:rPr sz="1050" b="0" i="0">
+                <a:solidFill>
+                  <a:srgbClr val="5A5A5A"/>
+                </a:solidFill>
+                <a:latin typeface="Calibri"/>
+                <a:hlinkClick r:id="rId26"/>
+              </a:rPr>
+              <a:t>Harding early warning, PLoS ONE 2011</a:t>
+            </a:r>
+          </a:p>
+        </p:txBody>
+      </p:sp>
+      <p:sp>
+        <p:nvSpPr>
+          <p:cNvPr id="133" name="R6 build"/>
+          <p:cNvSpPr txBox="1"/>
+          <p:nvPr/>
+        </p:nvSpPr>
+        <p:spPr>
+          <a:xfrm>
+            <a:off x="731520" y="6053328"/>
+            <a:ext cx="16824960" cy="384048"/>
+          </a:xfrm>
+          <a:prstGeom prst="rect">
+            <a:avLst/>
+          </a:prstGeom>
+          <a:noFill/>
+        </p:spPr>
+        <p:txBody>
+          <a:bodyPr wrap="square" anchor="ctr" lIns="45720" rIns="45720" tIns="18288" bIns="18288"/>
+          <a:lstStyle/>
+          <a:p>
+            <a:pPr algn="l"/>
+            <a:r>
+              <a:rPr sz="1050" b="1" i="0">
+                <a:solidFill>
+                  <a:srgbClr val="1E2761"/>
+                </a:solidFill>
+                <a:latin typeface="Calibri"/>
+              </a:rPr>
+              <a:t>Build from:  </a:t>
+            </a:r>
+            <a:r>
+              <a:rPr sz="1050" b="0" i="0">
+                <a:solidFill>
+                  <a:srgbClr val="5A5A5A"/>
+                </a:solidFill>
+                <a:latin typeface="Calibri"/>
+                <a:hlinkClick r:id="rId11"/>
+              </a:rPr>
+              <a:t>DM-Count code (MIT)  </a:t>
+            </a:r>
+            <a:r>
+              <a:rPr sz="1050" b="0" i="0">
+                <a:solidFill>
+                  <a:srgbClr val="5A5A5A"/>
+                </a:solidFill>
+                <a:latin typeface="Calibri"/>
+                <a:hlinkClick r:id="rId27"/>
+              </a:rPr>
+              <a:t>CSRNet model  </a:t>
+            </a:r>
+            <a:r>
+              <a:rPr sz="1050" b="0" i="0">
+                <a:solidFill>
+                  <a:srgbClr val="5A5A5A"/>
+                </a:solidFill>
+                <a:latin typeface="Calibri"/>
+                <a:hlinkClick r:id="rId28"/>
+              </a:rPr>
+              <a:t>homography calibrator  </a:t>
+            </a:r>
+            <a:r>
+              <a:rPr sz="1050" b="0" i="0">
+                <a:solidFill>
+                  <a:srgbClr val="5A5A5A"/>
+                </a:solidFill>
+                <a:latin typeface="Calibri"/>
+                <a:hlinkClick r:id="rId29"/>
+              </a:rPr>
+              <a:t>DeepStream custom-model docs</a:t>
             </a:r>
           </a:p>
         </p:txBody>

</xml_diff>

<commit_message>
feat: slide 2 goes all-Indian - Kumbh timeline, Hathras and Mumbai fact cards
</commit_message>
<xml_diff>
--- a/deck/Raksha_Hackathon2026_Simplified.pptx
+++ b/deck/Raksha_Hackathon2026_Simplified.pptx
@@ -5447,11 +5447,10 @@
                 </a:solidFill>
                 <a:latin typeface="Calibri"/>
               </a:rPr>
-              <a:t>Kumbh 2025</a:t>
-            </a:r>
-          </a:p>
-          <a:p>
-            <a:pPr algn="l"/>
+              <a:t>Hathras 2024</a:t>
+            </a:r>
+          </a:p>
+          <a:p>
             <a:r>
               <a:rPr sz="1500" b="0" i="0">
                 <a:solidFill>
@@ -5459,7 +5458,7 @@
                 </a:solidFill>
                 <a:latin typeface="Calibri"/>
               </a:rPr>
-              <a:t>2,751 cameras and AI alerts were live. The crush still killed 30.</a:t>
+              <a:t>121 dead. 80k permit, 250k crowd. Exits blocked.</a:t>
             </a:r>
           </a:p>
         </p:txBody>
@@ -5513,11 +5512,10 @@
                 </a:solidFill>
                 <a:latin typeface="Calibri"/>
               </a:rPr>
-              <a:t>Itaewon 2022</a:t>
-            </a:r>
-          </a:p>
-          <a:p>
-            <a:pPr algn="l"/>
+              <a:t>Mumbai 2017</a:t>
+            </a:r>
+          </a:p>
+          <a:p>
             <a:r>
               <a:rPr sz="1500" b="0" i="0">
                 <a:solidFill>
@@ -5525,7 +5523,7 @@
                 </a:solidFill>
                 <a:latin typeface="Calibri"/>
               </a:rPr>
-              <a:t>159 dead in a 3.2 metre alley. 11 calls ignored. No machine spoke up.</a:t>
+              <a:t>23 dead on a station footbridge. Rain, rush hour, no metering.</a:t>
             </a:r>
           </a:p>
         </p:txBody>
@@ -5634,7 +5632,7 @@
                 </a:solidFill>
                 <a:latin typeface="Calibri"/>
               </a:rPr>
-              <a:t>Four hours of human warning. No machine ever paged anyone.</a:t>
+              <a:t>The system saw it coming. No gate opened.</a:t>
             </a:r>
           </a:p>
         </p:txBody>
@@ -5758,7 +5756,7 @@
                 </a:solidFill>
                 <a:latin typeface="Calibri"/>
               </a:rPr>
-              <a:t>Itaewon, 29 October 2022</a:t>
+              <a:t>Kumbh, 29 January 2025</a:t>
             </a:r>
           </a:p>
         </p:txBody>
@@ -5834,11 +5832,8 @@
                 </a:solidFill>
                 <a:latin typeface="Calibri"/>
               </a:rPr>
-              <a:t>18:34</a:t>
-            </a:r>
-          </a:p>
-          <a:p>
-            <a:pPr algn="l"/>
+              <a:t>Months before</a:t>
+            </a:r>
             <a:r>
               <a:rPr sz="1400" b="0" i="0">
                 <a:solidFill>
@@ -5846,7 +5841,8 @@
                 </a:solidFill>
                 <a:latin typeface="Calibri"/>
               </a:rPr>
-              <a:t>First distress calls from the packed alley.</a:t>
+              <a:t>
+2,751 cameras and AI alerts go live.</a:t>
             </a:r>
           </a:p>
         </p:txBody>
@@ -5922,11 +5918,8 @@
                 </a:solidFill>
                 <a:latin typeface="Calibri"/>
               </a:rPr>
-              <a:t>hours pass</a:t>
-            </a:r>
-          </a:p>
-          <a:p>
-            <a:pPr algn="l"/>
+              <a:t>01:00</a:t>
+            </a:r>
             <a:r>
               <a:rPr sz="1400" b="0" i="0">
                 <a:solidFill>
@@ -5934,7 +5927,8 @@
                 </a:solidFill>
                 <a:latin typeface="Calibri"/>
               </a:rPr>
-              <a:t>Calls keep coming. No machine raises an alarm.</a:t>
+              <a:t>
+Barricades jumped at the Sangam nose. Crores press forward.</a:t>
             </a:r>
           </a:p>
         </p:txBody>
@@ -6010,11 +6004,8 @@
                 </a:solidFill>
                 <a:latin typeface="Calibri"/>
               </a:rPr>
-              <a:t>22:15</a:t>
-            </a:r>
-          </a:p>
-          <a:p>
-            <a:pPr algn="l"/>
+              <a:t>After</a:t>
+            </a:r>
             <a:r>
               <a:rPr sz="1400" b="0" i="0">
                 <a:solidFill>
@@ -6022,7 +6013,8 @@
                 </a:solidFill>
                 <a:latin typeface="Calibri"/>
               </a:rPr>
-              <a:t>The alley locks. 159 dead, 196 injured.</a:t>
+              <a:t>
+30 dead officially. The alarm watched. Nobody acted.</a:t>
             </a:r>
           </a:p>
         </p:txBody>

</xml_diff>

<commit_message>
fix: remove side-track box, ring-buffer evidence logic, PTZ fallback
</commit_message>
<xml_diff>
--- a/deck/Raksha_Hackathon2026_Simplified.pptx
+++ b/deck/Raksha_Hackathon2026_Simplified.pptx
@@ -7103,7 +7103,7 @@
                 </a:solidFill>
                 <a:latin typeface="Calibri"/>
               </a:rPr>
-              <a:t>Side track, kept</a:t>
+              <a:t>Warns before stillness</a:t>
             </a:r>
           </a:p>
           <a:p>
@@ -7115,7 +7115,7 @@
                 </a:solidFill>
                 <a:latin typeface="Calibri"/>
               </a:rPr>
-              <a:t>Below 2 people per m2, box IDs still run and feed the dossier. Already built.</a:t>
+              <a:t>Stop-and-go waves and rising pressure fire the alert while feet still move. Stillness is the accident, never the trigger.</a:t>
             </a:r>
           </a:p>
         </p:txBody>
@@ -7612,13 +7612,13 @@
           <a:p>
             <a:pPr algn="l"/>
             <a:r>
-              <a:rPr sz="1500" b="0" i="0">
+              <a:rPr sz="1400" b="0" i="0">
                 <a:solidFill>
                   <a:srgbClr val="111111"/>
                 </a:solidFill>
                 <a:latin typeface="Calibri"/>
               </a:rPr>
-              <a:t>Each edge box sends small JSON numbers, never raw video. Footage is discarded at the camera.</a:t>
+              <a:t>Each edge box keeps a 10-minute rolling buffer and sends small JSON numbers, never raw video. Only a confirmed Red alert exports its clip, signed, to the evidence pack.</a:t>
             </a:r>
           </a:p>
         </p:txBody>
@@ -7684,7 +7684,7 @@
                 </a:solidFill>
                 <a:latin typeface="Calibri"/>
               </a:rPr>
-              <a:t>Fixed gates are measured once. Kumbh ran 3-month camera surveys for its crowd alarm. Other views use relative levels.</a:t>
+              <a:t>Fixed gates are measured once. Kumbh ran 3-month camera surveys for its crowd alarm. PTZ or moved cameras fall back to relative levels until re-measured.</a:t>
             </a:r>
           </a:p>
         </p:txBody>
@@ -8816,9 +8816,7 @@
           </a:effectLst>
         </p:spPr>
         <p:txBody>
-          <a:bodyPr wrap="square" lIns="320040" tIns="109728" rIns="320040" bIns="109728" anchor="ctr" rtlCol="0">
-            <a:noAutofit/>
-          </a:bodyPr>
+          <a:bodyPr wrap="square" lIns="45720" tIns="18288" rIns="45720" bIns="18288" anchor="ctr" rtlCol="0"/>
           <a:lstStyle/>
           <a:p>
             <a:pPr algn="l">
@@ -8830,37 +8828,25 @@
               </a:spcAft>
             </a:pPr>
             <a:r>
-              <a:rPr lang="en-US" sz="2200" b="1" i="0" dirty="0">
+              <a:rPr sz="2000" b="1" i="0">
                 <a:solidFill>
                   <a:srgbClr val="1E2761"/>
                 </a:solidFill>
                 <a:latin typeface="Calibri"/>
-                <a:cs typeface="Calibri"/>
               </a:rPr>
               <a:t>Police</a:t>
             </a:r>
           </a:p>
           <a:p>
-            <a:pPr algn="l">
-              <a:lnSpc>
-                <a:spcPct val="100000"/>
-              </a:lnSpc>
-              <a:spcBef>
-                <a:spcPts val="0"/>
-              </a:spcBef>
-              <a:spcAft>
-                <a:spcPts val="0"/>
-              </a:spcAft>
-            </a:pPr>
-            <a:r>
-              <a:rPr lang="en-US" sz="1800" b="0" i="0" dirty="0">
+            <a:pPr algn="l"/>
+            <a:r>
+              <a:rPr sz="1500" b="0" i="0">
                 <a:solidFill>
                   <a:srgbClr val="111111"/>
                 </a:solidFill>
                 <a:latin typeface="Calibri"/>
-                <a:cs typeface="Calibri"/>
-              </a:rPr>
-              <a:t>Every alert, zone and action exports as one evidence pack in a click.</a:t>
+              </a:rPr>
+              <a:t>Every alert, zone and action exports as one evidence pack in a click, with the signed 10-minute incident clip.</a:t>
             </a:r>
           </a:p>
         </p:txBody>

</xml_diff>

<commit_message>
fix: escalation teeth, F1 attribution, pressure formula+threshold, cost model, DPDP, FP-rate pledge
</commit_message>
<xml_diff>
--- a/deck/Raksha_Hackathon2026_Simplified.pptx
+++ b/deck/Raksha_Hackathon2026_Simplified.pptx
@@ -6983,7 +6983,7 @@
                 </a:solidFill>
                 <a:latin typeface="Calibri"/>
               </a:rPr>
-              <a:t>At crush density a detector scores F1 0.07 against 0.71 point-based. Counting error fell from 68 to 49 MAE. (NWPU-Crowd, ShanghaiTech)</a:t>
+              <a:t>Box detectors collapse under overlap: F1 0.07 vs 0.71 point-based. Density maps cut counting error 265 to 105 MAE. (NWPU-Crowd)</a:t>
             </a:r>
           </a:p>
         </p:txBody>
@@ -7109,13 +7109,13 @@
           <a:p>
             <a:pPr algn="l"/>
             <a:r>
-              <a:rPr sz="1350" b="0" i="0">
+              <a:rPr sz="1300" b="0" i="0">
                 <a:solidFill>
                   <a:srgbClr val="111111"/>
                 </a:solidFill>
                 <a:latin typeface="Calibri"/>
               </a:rPr>
-              <a:t>Stop-and-go waves and rising pressure fire the alert while feet still move. Stillness is the accident, never the trigger.</a:t>
+              <a:t>Stop-and-go waves and rising pressure fire the alert while feet still move. Shown on Hajj 2006 footage; multi-site trials are the pilot's job.</a:t>
             </a:r>
           </a:p>
         </p:txBody>
@@ -7299,7 +7299,7 @@
                 </a:solidFill>
                 <a:latin typeface="Calibri"/>
               </a:rPr>
-              <a:t>Head-density surface from video (Johansson 2008).</a:t>
+              <a:t>Head-density surface: each peak is one head, the sum is the count. (Johansson 2008).</a:t>
             </a:r>
           </a:p>
         </p:txBody>
@@ -7684,7 +7684,7 @@
                 </a:solidFill>
                 <a:latin typeface="Calibri"/>
               </a:rPr>
-              <a:t>Fixed gates are measured once. Kumbh ran 3-month camera surveys for its crowd alarm. PTZ or moved cameras fall back to relative levels until re-measured.</a:t>
+              <a:t>Fixed gates are measured once; Kumbh ran 3-month surveys for its alarm. Open grounds and PTZ cameras run relative levels plus entry counts.</a:t>
             </a:r>
           </a:p>
         </p:txBody>
@@ -7744,13 +7744,13 @@
           <a:p>
             <a:pPr algn="l"/>
             <a:r>
-              <a:rPr sz="1500" b="0" i="0">
+              <a:rPr sz="1400" b="0" i="0">
                 <a:solidFill>
                   <a:srgbClr val="111111"/>
                 </a:solidFill>
                 <a:latin typeface="Calibri"/>
               </a:rPr>
-              <a:t>Heatmaps cannot show a face. Saved video is blurred, wiped after 7 days, zero identity in core.</a:t>
+              <a:t>Heatmaps cannot show a face. Saved video is blurred, wiped after 7 days, zero identity in core. Police clips are access-logged under DPDP Act 2023 rules.</a:t>
             </a:r>
           </a:p>
         </p:txBody>
@@ -8298,13 +8298,13 @@
           <a:p>
             <a:pPr algn="l"/>
             <a:r>
-              <a:rPr sz="1400" b="0" i="0">
+              <a:rPr sz="1300" b="0" i="0">
                 <a:solidFill>
                   <a:srgbClr val="5A5A5A"/>
                 </a:solidFill>
                 <a:latin typeface="Calibri"/>
               </a:rPr>
-              <a:t>Raw video never leaves the camera box.</a:t>
+              <a:t>One Jetson-class box (about $250, 15 watts) per 1 to 4 cameras. Reuses existing CCTV. Pilot covers night, rain, oblique angles.</a:t>
             </a:r>
           </a:p>
         </p:txBody>
@@ -8436,13 +8436,13 @@
           <a:p>
             <a:pPr algn="l"/>
             <a:r>
-              <a:rPr sz="1200" b="0" i="0">
+              <a:rPr sz="1150" b="0" i="0">
                 <a:solidFill>
                   <a:srgbClr val="111111"/>
                 </a:solidFill>
                 <a:latin typeface="Calibri"/>
               </a:rPr>
-              <a:t>Pressure crossed the warning line before turbulence began. The accident came after. Hajj 2006 data (Johansson et al.).</a:t>
+              <a:t>Pressure p = density x velocity variance. Hajj 2006: turbulence onset at 0.02 per s2, accident after. (Johansson et al.)</a:t>
             </a:r>
           </a:p>
         </p:txBody>
@@ -8714,7 +8714,7 @@
                 </a:solidFill>
                 <a:latin typeface="Calibri"/>
               </a:rPr>
-              <a:t>Pressure rising at Gate B opens overflow at Gate A upstream. Security acts before the jam, not after.</a:t>
+              <a:t>Pressure at Gate B opens overflow at Gate A upstream. Every red has an owner, a timer, and a log.</a:t>
             </a:r>
           </a:p>
         </p:txBody>
@@ -9091,7 +9091,7 @@
                 </a:solidFill>
                 <a:latin typeface="Calibri"/>
               </a:rPr>
-              <a:t>Guards watch the zone closely. Overflow gates get ready.</a:t>
+              <a:t>Auto-pages the zone guard with an ack timer. Overflow gates get ready.</a:t>
             </a:r>
           </a:p>
         </p:txBody>
@@ -9179,7 +9179,7 @@
                 </a:solidFill>
                 <a:latin typeface="Calibri"/>
               </a:rPr>
-              <a:t>Guards get steps on their handsets; a human confirms before any PA or door release.</a:t>
+              <a:t>Guards get steps on their handsets and confirm. Unanswered reds climb the chain automatically.</a:t>
             </a:r>
           </a:p>
         </p:txBody>
@@ -9343,7 +9343,7 @@
                 </a:solidFill>
                 <a:latin typeface="Calibri"/>
               </a:rPr>
-              <a:t>Pilot targets: warn before critical, page guards in seconds, log every step.</a:t>
+              <a:t>Pilot targets: warn before critical, page guards in seconds, publish the false-alarm rate, log every step.</a:t>
             </a:r>
           </a:p>
         </p:txBody>
@@ -10631,7 +10631,7 @@
                 </a:solidFill>
                 <a:latin typeface="Calibri"/>
               </a:rPr>
-              <a:t>Build from:  </a:t>
+              <a:t>Status: idea stage, side-track demo built. Build from:  </a:t>
             </a:r>
             <a:r>
               <a:rPr sz="1050" b="0" i="0">

</xml_diff>

<commit_message>
fix: idea-stage honesty - prior-art framing, escalation tiers, unit-clean pressure, cost, status
</commit_message>
<xml_diff>
--- a/deck/Raksha_Hackathon2026_Simplified.pptx
+++ b/deck/Raksha_Hackathon2026_Simplified.pptx
@@ -6983,7 +6983,7 @@
                 </a:solidFill>
                 <a:latin typeface="Calibri"/>
               </a:rPr>
-              <a:t>Box detectors collapse under overlap: F1 0.07 vs 0.71 point-based. Density maps cut counting error 265 to 105 MAE. (NWPU-Crowd)</a:t>
+              <a:t>Published research shows box detectors collapse under overlap: F1 0.07 vs 0.71 point-based. Density maps cut counting error 265 to 105 MAE. (NWPU-Crowd)</a:t>
             </a:r>
           </a:p>
         </p:txBody>
@@ -8442,7 +8442,7 @@
                 </a:solidFill>
                 <a:latin typeface="Calibri"/>
               </a:rPr>
-              <a:t>Pressure p = density x velocity variance. Hajj 2006: turbulence onset at 0.02 per s2, accident after. (Johansson et al.)</a:t>
+              <a:t>Pressure (density x movement variance) crossed its warning line before turbulence began. The accident came after. Hajj 2006 data (Johansson et al.).</a:t>
             </a:r>
           </a:p>
         </p:txBody>
@@ -8708,13 +8708,13 @@
           <a:p>
             <a:pPr algn="l"/>
             <a:r>
-              <a:rPr sz="1600" b="1" i="0">
+              <a:rPr sz="1500" b="1" i="0">
                 <a:solidFill>
                   <a:srgbClr val="FFFFFF"/>
                 </a:solidFill>
                 <a:latin typeface="Calibri"/>
               </a:rPr>
-              <a:t>Pressure at Gate B opens overflow at Gate A upstream. Every red has an owner, a timer, and a log.</a:t>
+              <a:t>Pressure at Gate B opens overflow at Gate A upstream. Kumbh's system watched without forcing an answer. Ours requires one.</a:t>
             </a:r>
           </a:p>
         </p:txBody>
@@ -9091,7 +9091,7 @@
                 </a:solidFill>
                 <a:latin typeface="Calibri"/>
               </a:rPr>
-              <a:t>Auto-pages the zone guard with an ack timer. Overflow gates get ready.</a:t>
+              <a:t>Auto-pages the zone guard with a 2-minute ack timer. Overflow gates get ready.</a:t>
             </a:r>
           </a:p>
         </p:txBody>
@@ -9179,7 +9179,7 @@
                 </a:solidFill>
                 <a:latin typeface="Calibri"/>
               </a:rPr>
-              <a:t>Guards get steps on their handsets and confirm. Unanswered reds climb the chain automatically.</a:t>
+              <a:t>Guards confirm on handsets; unanswered reds climb to venue command, then city control.</a:t>
             </a:r>
           </a:p>
         </p:txBody>
@@ -9337,13 +9337,13 @@
           <a:p>
             <a:pPr algn="l"/>
             <a:r>
-              <a:rPr sz="1500" b="1" i="0">
+              <a:rPr sz="1400" b="1" i="0">
                 <a:solidFill>
                   <a:srgbClr val="1E2761"/>
                 </a:solidFill>
                 <a:latin typeface="Calibri"/>
               </a:rPr>
-              <a:t>Pilot targets: warn before critical, page guards in seconds, publish the false-alarm rate, log every step.</a:t>
+              <a:t>Pilot targets: warn before critical, page guards in seconds, publish the false-alarm rate, log every step. Still to prove: thresholds across venue types, calibration without surveys.</a:t>
             </a:r>
           </a:p>
         </p:txBody>
@@ -10611,8 +10611,8 @@
         </p:nvSpPr>
         <p:spPr>
           <a:xfrm>
-            <a:off x="731520" y="6053328"/>
-            <a:ext cx="16824960" cy="384048"/>
+            <a:off x="731520" y="5989320"/>
+            <a:ext cx="16824960" cy="566928"/>
           </a:xfrm>
           <a:prstGeom prst="rect">
             <a:avLst/>
@@ -10631,10 +10631,22 @@
                 </a:solidFill>
                 <a:latin typeface="Calibri"/>
               </a:rPr>
-              <a:t>Status: idea stage, side-track demo built. Build from:  </a:t>
-            </a:r>
-            <a:r>
-              <a:rPr sz="1050" b="0" i="0">
+              <a:t>Status: idea stage. Numbers above are published research we build on, not our measurements.</a:t>
+            </a:r>
+          </a:p>
+          <a:p>
+            <a:pPr algn="l"/>
+            <a:r>
+              <a:rPr sz="1000" b="0" i="0">
+                <a:solidFill>
+                  <a:srgbClr val="1E2761"/>
+                </a:solidFill>
+                <a:latin typeface="Calibri"/>
+              </a:rPr>
+              <a:t>Build from:  </a:t>
+            </a:r>
+            <a:r>
+              <a:rPr sz="1000" b="0" i="0">
                 <a:solidFill>
                   <a:srgbClr val="5A5A5A"/>
                 </a:solidFill>
@@ -10644,7 +10656,7 @@
               <a:t>DM-Count code (MIT)  </a:t>
             </a:r>
             <a:r>
-              <a:rPr sz="1050" b="0" i="0">
+              <a:rPr sz="1000" b="0" i="0">
                 <a:solidFill>
                   <a:srgbClr val="5A5A5A"/>
                 </a:solidFill>
@@ -10654,7 +10666,7 @@
               <a:t>CSRNet model  </a:t>
             </a:r>
             <a:r>
-              <a:rPr sz="1050" b="0" i="0">
+              <a:rPr sz="1000" b="0" i="0">
                 <a:solidFill>
                   <a:srgbClr val="5A5A5A"/>
                 </a:solidFill>
@@ -10664,14 +10676,14 @@
               <a:t>homography calibrator  </a:t>
             </a:r>
             <a:r>
-              <a:rPr sz="1050" b="0" i="0">
+              <a:rPr sz="1000" b="0" i="0">
                 <a:solidFill>
                   <a:srgbClr val="5A5A5A"/>
                 </a:solidFill>
                 <a:latin typeface="Calibri"/>
                 <a:hlinkClick r:id="rId29"/>
               </a:rPr>
-              <a:t>DeepStream custom-model docs</a:t>
+              <a:t>DeepStream docs</a:t>
             </a:r>
           </a:p>
         </p:txBody>

</xml_diff>

<commit_message>
fix: soften Kumbh claims to outcome-based wording
</commit_message>
<xml_diff>
--- a/deck/Raksha_Hackathon2026_Simplified.pptx
+++ b/deck/Raksha_Hackathon2026_Simplified.pptx
@@ -5632,7 +5632,7 @@
                 </a:solidFill>
                 <a:latin typeface="Calibri"/>
               </a:rPr>
-              <a:t>The system saw it coming. No gate opened.</a:t>
+              <a:t>Alerts existed. Action did not follow in time.</a:t>
             </a:r>
           </a:p>
         </p:txBody>
@@ -5998,7 +5998,7 @@
           <a:p>
             <a:pPr algn="l"/>
             <a:r>
-              <a:rPr sz="1600" b="1" i="0">
+              <a:rPr sz="1600" b="1">
                 <a:solidFill>
                   <a:srgbClr val="1E2761"/>
                 </a:solidFill>
@@ -6007,14 +6007,14 @@
               <a:t>After</a:t>
             </a:r>
             <a:r>
-              <a:rPr sz="1400" b="0" i="0">
+              <a:rPr sz="1400" b="0">
                 <a:solidFill>
                   <a:srgbClr val="111111"/>
                 </a:solidFill>
                 <a:latin typeface="Calibri"/>
               </a:rPr>
               <a:t>
-30 dead officially. The alarm watched. Nobody acted.</a:t>
+30 dead officially, despite live AI alerts. No action followed in time.</a:t>
             </a:r>
           </a:p>
         </p:txBody>
@@ -8706,7 +8706,6 @@
             </a:r>
           </a:p>
           <a:p>
-            <a:pPr algn="l"/>
             <a:r>
               <a:rPr sz="1500" b="1" i="0">
                 <a:solidFill>
@@ -8714,7 +8713,7 @@
                 </a:solidFill>
                 <a:latin typeface="Calibri"/>
               </a:rPr>
-              <a:t>Pressure at Gate B opens overflow at Gate A upstream. Kumbh's system watched without forcing an answer. Ours requires one.</a:t>
+              <a:t>Pressure at Gate B opens overflow at Gate A upstream. Kumbh's alarms reportedly went unactioned; ours forces an answer: owner, timer, log.</a:t>
             </a:r>
           </a:p>
         </p:txBody>

</xml_diff>

<commit_message>
fix: cite Kumbh/Hathras sources, soften DPDP, pilot wording, delivery-vs-ack clarity
</commit_message>
<xml_diff>
--- a/deck/Raksha_Hackathon2026_Simplified.pptx
+++ b/deck/Raksha_Hackathon2026_Simplified.pptx
@@ -7750,7 +7750,7 @@
                 </a:solidFill>
                 <a:latin typeface="Calibri"/>
               </a:rPr>
-              <a:t>Heatmaps cannot show a face. Saved video is blurred, wiped after 7 days, zero identity in core. Police clips are access-logged under DPDP Act 2023 rules.</a:t>
+              <a:t>Heatmaps cannot show a face. Saved video is blurred, wiped after 7 days, zero identity in core. Police clips are access-logged, designed to align with DPDP Act 2023 principles.</a:t>
             </a:r>
           </a:p>
         </p:txBody>
@@ -8304,7 +8304,7 @@
                 </a:solidFill>
                 <a:latin typeface="Calibri"/>
               </a:rPr>
-              <a:t>One Jetson-class box (about $250, 15 watts) per 1 to 4 cameras. Reuses existing CCTV. Pilot covers night, rain, oblique angles.</a:t>
+              <a:t>One Jetson-class box (about $250, 15 watts) per 1 to 4 cameras. Reuses existing CCTV. Pilot will test night, rain, oblique angles.</a:t>
             </a:r>
           </a:p>
         </p:txBody>
@@ -9342,7 +9342,7 @@
                 </a:solidFill>
                 <a:latin typeface="Calibri"/>
               </a:rPr>
-              <a:t>Pilot targets: warn before critical, page guards in seconds, publish the false-alarm rate, log every step. Still to prove: thresholds across venue types, calibration without surveys.</a:t>
+              <a:t>Pilot targets: warn before critical, alerts reach guards in seconds, publish the false-alarm rate, log every step. Still to prove: thresholds across venue types, calibration without surveys.</a:t>
             </a:r>
           </a:p>
         </p:txBody>
@@ -9697,6 +9697,18 @@
                 <a:latin typeface="Calibri"/>
               </a:rPr>
               <a:t>30 dead, Jan 2025, with AI live. 121 dead, Jul 2024, 80k permit vs 250k crowd.</a:t>
+            </a:r>
+          </a:p>
+          <a:p>
+            <a:pPr algn="l"/>
+            <a:r>
+              <a:rPr sz="1050">
+                <a:solidFill>
+                  <a:srgbClr val="FFFFFF"/>
+                </a:solidFill>
+                <a:latin typeface="Calibri"/>
+              </a:rPr>
+              <a:t>Sources: Indian Express (Kumbh tech), AP (Hathras).</a:t>
             </a:r>
           </a:p>
         </p:txBody>

</xml_diff>

<commit_message>
chore: apply reorganisation path fixes, the MCP rule, and the rebuilt deck
- AGENTS.md: record the never-nuke-node.exe rule, and how to reconnect MCP
  servers without restarting the service
- point paths at the reorganised workspace (research/ -> learning/research/,
  gallery/ -> raksha/gallery/) across backend, vision, and the scripts
- refresh the simplified deck and its exported PDF
</commit_message>
<xml_diff>
--- a/deck/Raksha_Hackathon2026_Simplified.pptx
+++ b/deck/Raksha_Hackathon2026_Simplified.pptx
@@ -5826,7 +5826,7 @@
           <a:p>
             <a:pPr algn="l"/>
             <a:r>
-              <a:rPr sz="1600" b="1" i="0">
+              <a:rPr sz="1600" b="1">
                 <a:solidFill>
                   <a:srgbClr val="1E2761"/>
                 </a:solidFill>
@@ -5835,14 +5835,14 @@
               <a:t>Months before</a:t>
             </a:r>
             <a:r>
-              <a:rPr sz="1400" b="0" i="0">
+              <a:rPr sz="1400" b="0">
                 <a:solidFill>
                   <a:srgbClr val="111111"/>
                 </a:solidFill>
                 <a:latin typeface="Calibri"/>
               </a:rPr>
               <a:t>
-2,751 cameras and AI alerts go live.</a:t>
+2,751 cameras and AI alerts go live (TOI).</a:t>
             </a:r>
           </a:p>
         </p:txBody>
@@ -6688,13 +6688,13 @@
               </a:spcAft>
             </a:pPr>
             <a:r>
-              <a:rPr sz="1500" b="0" i="0">
+              <a:rPr sz="1350" b="0" i="0">
                 <a:solidFill>
                   <a:srgbClr val="5A5A5A"/>
                 </a:solidFill>
                 <a:latin typeface="Calibri"/>
               </a:rPr>
-              <a:t>density times movement</a:t>
+              <a:t>density x movement variance</a:t>
             </a:r>
           </a:p>
         </p:txBody>
@@ -7049,7 +7049,7 @@
                 </a:solidFill>
                 <a:latin typeface="Calibri"/>
               </a:rPr>
-              <a:t>Pressure is density times uneven movement. Density or speed alone cannot warn. (Johansson 2008)</a:t>
+              <a:t>Pressure is density times movement variance. Density or speed alone cannot warn. (Johansson 2008)</a:t>
             </a:r>
           </a:p>
         </p:txBody>
@@ -7612,13 +7612,13 @@
           <a:p>
             <a:pPr algn="l"/>
             <a:r>
-              <a:rPr sz="1400" b="0" i="0">
+              <a:rPr sz="1350" b="0" i="0">
                 <a:solidFill>
                   <a:srgbClr val="111111"/>
                 </a:solidFill>
                 <a:latin typeface="Calibri"/>
               </a:rPr>
-              <a:t>Each edge box keeps a 10-minute rolling buffer and sends small JSON numbers, never raw video. Only a confirmed Red alert exports its clip, signed, to the evidence pack.</a:t>
+              <a:t>Each edge box keeps a 10-minute rolling buffer and sends JSON numbers over site LAN or 4G failover. Only a confirmed Red alert exports its clip, signed.</a:t>
             </a:r>
           </a:p>
         </p:txBody>
@@ -8077,7 +8077,7 @@
                 </a:solidFill>
                 <a:latin typeface="Calibri"/>
               </a:rPr>
-              <a:t>Sends JSON numbers only, never video</a:t>
+              <a:t>Sends JSON numbers, not continuous video</a:t>
             </a:r>
           </a:p>
         </p:txBody>
@@ -8168,13 +8168,13 @@
           <a:p>
             <a:pPr algn="ctr"/>
             <a:r>
-              <a:rPr sz="1500" b="1" i="0">
+              <a:rPr sz="1400" b="1" i="0">
                 <a:solidFill>
                   <a:srgbClr val="FFFFFF"/>
                 </a:solidFill>
                 <a:latin typeface="Calibri"/>
               </a:rPr>
-              <a:t>Venue server: fuses every camera into one map</a:t>
+              <a:t>Venue servers (paired): fuse every camera into one map</a:t>
             </a:r>
           </a:p>
         </p:txBody>
@@ -8284,8 +8284,8 @@
         </p:nvSpPr>
         <p:spPr>
           <a:xfrm>
-            <a:off x="1005840" y="8641080"/>
-            <a:ext cx="7680960" cy="731520"/>
+            <a:off x="1005840" y="8595360"/>
+            <a:ext cx="7680960" cy="868680"/>
           </a:xfrm>
           <a:prstGeom prst="rect">
             <a:avLst/>
@@ -8298,13 +8298,13 @@
           <a:p>
             <a:pPr algn="l"/>
             <a:r>
-              <a:rPr sz="1300" b="0" i="0">
+              <a:rPr sz="1250" b="0" i="0">
                 <a:solidFill>
                   <a:srgbClr val="5A5A5A"/>
                 </a:solidFill>
                 <a:latin typeface="Calibri"/>
               </a:rPr>
-              <a:t>One Jetson-class box (about $250, 15 watts) per 1 to 4 cameras. Reuses existing CCTV. Pilot will test night, rain, oblique angles.</a:t>
+              <a:t>Compute target: 5 to 10 FPS per camera at reduced resolution; pressure moves over seconds, not frames. About $250 and 15 watts per edge box (1 to 4 cameras); server, handsets, network extra. Reuses existing CCTV.</a:t>
             </a:r>
           </a:p>
         </p:txBody>
@@ -9178,7 +9178,7 @@
                 </a:solidFill>
                 <a:latin typeface="Calibri"/>
               </a:rPr>
-              <a:t>Guards confirm on handsets; unanswered reds climb to venue command, then city control.</a:t>
+              <a:t>Guards confirm on handsets; unanswered reds climb to venue command, then city control (planned link).</a:t>
             </a:r>
           </a:p>
         </p:txBody>
@@ -9322,8 +9322,8 @@
         </p:nvSpPr>
         <p:spPr>
           <a:xfrm>
-            <a:off x="1005840" y="8732519"/>
-            <a:ext cx="7132320" cy="502919"/>
+            <a:off x="1005840" y="8485632"/>
+            <a:ext cx="7132320" cy="1115568"/>
           </a:xfrm>
           <a:prstGeom prst="rect">
             <a:avLst/>
@@ -9336,13 +9336,13 @@
           <a:p>
             <a:pPr algn="l"/>
             <a:r>
-              <a:rPr sz="1400" b="1" i="0">
+              <a:rPr sz="1250" b="1">
                 <a:solidFill>
                   <a:srgbClr val="1E2761"/>
                 </a:solidFill>
                 <a:latin typeface="Calibri"/>
               </a:rPr>
-              <a:t>Pilot targets: warn before critical, alerts reach guards in seconds, publish the false-alarm rate, log every step. Still to prove: thresholds across venue types, calibration without surveys.</a:t>
+              <a:t>Pilot targets: warn before critical, alerts reach guards in seconds, publish the false-alarm rate. Still to prove: thresholds, survey-free calibration, night/rain/angle tests.</a:t>
             </a:r>
           </a:p>
         </p:txBody>
@@ -9684,31 +9684,31 @@
                 </a:solidFill>
                 <a:latin typeface="Calibri"/>
               </a:rPr>
-              <a:t>Kumbh and Hathras</a:t>
+              <a:t>Three Indian disasters</a:t>
             </a:r>
           </a:p>
           <a:p>
             <a:pPr algn="l"/>
             <a:r>
-              <a:rPr sz="1300" b="0" i="0">
+              <a:rPr sz="1250" b="0" i="0">
                 <a:solidFill>
                   <a:srgbClr val="FFFFFF"/>
                 </a:solidFill>
                 <a:latin typeface="Calibri"/>
               </a:rPr>
-              <a:t>30 dead, Jan 2025, with AI live. 121 dead, Jul 2024, 80k permit vs 250k crowd.</a:t>
+              <a:t>Kumbh, Jan 2025: 30 dead, AI live. Hathras, Jul 2024: 121 dead, 80k vs 250k. Mumbai, Sep 2017: 23 dead, station footbridge.</a:t>
             </a:r>
           </a:p>
           <a:p>
             <a:pPr algn="l"/>
             <a:r>
-              <a:rPr sz="1050">
+              <a:rPr sz="1000" b="0" i="0">
                 <a:solidFill>
                   <a:srgbClr val="FFFFFF"/>
                 </a:solidFill>
                 <a:latin typeface="Calibri"/>
               </a:rPr>
-              <a:t>Sources: Indian Express (Kumbh tech), AP (Hathras).</a:t>
+              <a:t>Sources: Indian Express, Feb 2025; AP, Jul 2024; BBC, Sep 2017.</a:t>
             </a:r>
           </a:p>
         </p:txBody>

</xml_diff>